<commit_message>
Simplify maintainer briefing decks
</commit_message>
<xml_diff>
--- a/evaluation/dashboard/public/decks/uxl-oneccl-maintainer-briefing.pptx
+++ b/evaluation/dashboard/public/decks/uxl-oneccl-maintainer-briefing.pptx
@@ -2,20 +2,19 @@
 <file path=ppt/presentation.xml><?xml version="1.0" encoding="utf-8"?>
 <p:presentation xmlns:p="http://schemas.openxmlformats.org/presentationml/2006/main">
   <p:sldMasterIdLst>
-    <p:sldMasterId xmlns:r="http://schemas.openxmlformats.org/officeDocument/2006/relationships" id="2147483648" r:id="R2adc7912e30b41f2"/>
-    <p:sldMasterId xmlns:r="http://schemas.openxmlformats.org/officeDocument/2006/relationships" id="2147483665" r:id="R6a3ba7107e0b4410"/>
+    <p:sldMasterId xmlns:r="http://schemas.openxmlformats.org/officeDocument/2006/relationships" id="2147483648" r:id="Re0e0fd93dc0f4a1b"/>
+    <p:sldMasterId xmlns:r="http://schemas.openxmlformats.org/officeDocument/2006/relationships" id="2147483665" r:id="Rf01571311831434a"/>
   </p:sldMasterIdLst>
   <p:notesMasterIdLst>
-    <p:notesMasterId xmlns:r="http://schemas.openxmlformats.org/officeDocument/2006/relationships" r:id="R0b3d67f7f83a4d10"/>
+    <p:notesMasterId xmlns:r="http://schemas.openxmlformats.org/officeDocument/2006/relationships" r:id="R57bb29e9678c4f5c"/>
   </p:notesMasterIdLst>
   <p:sldIdLst>
-    <p:sldId xmlns:r="http://schemas.openxmlformats.org/officeDocument/2006/relationships" id="256" r:id="Ra5e97bf2674949f9"/>
-    <p:sldId xmlns:r="http://schemas.openxmlformats.org/officeDocument/2006/relationships" id="257" r:id="Rd090db69b4c54099"/>
-    <p:sldId xmlns:r="http://schemas.openxmlformats.org/officeDocument/2006/relationships" id="258" r:id="R1f076a1b0278482f"/>
-    <p:sldId xmlns:r="http://schemas.openxmlformats.org/officeDocument/2006/relationships" id="259" r:id="Rc5519593742a4072"/>
-    <p:sldId xmlns:r="http://schemas.openxmlformats.org/officeDocument/2006/relationships" id="260" r:id="Rfc4d6ddb1bd746c6"/>
-    <p:sldId xmlns:r="http://schemas.openxmlformats.org/officeDocument/2006/relationships" id="261" r:id="R66cae8eba7c74cb0"/>
-    <p:sldId xmlns:r="http://schemas.openxmlformats.org/officeDocument/2006/relationships" id="262" r:id="R300e94bb1b8144c2"/>
+    <p:sldId xmlns:r="http://schemas.openxmlformats.org/officeDocument/2006/relationships" id="256" r:id="R38123e27fbeb4381"/>
+    <p:sldId xmlns:r="http://schemas.openxmlformats.org/officeDocument/2006/relationships" id="257" r:id="R3d30f4742126454d"/>
+    <p:sldId xmlns:r="http://schemas.openxmlformats.org/officeDocument/2006/relationships" id="258" r:id="Rabe0f841331d4f03"/>
+    <p:sldId xmlns:r="http://schemas.openxmlformats.org/officeDocument/2006/relationships" id="259" r:id="Rb74f31b3cbd142b8"/>
+    <p:sldId xmlns:r="http://schemas.openxmlformats.org/officeDocument/2006/relationships" id="260" r:id="Ref29dc64ad704671"/>
+    <p:sldId xmlns:r="http://schemas.openxmlformats.org/officeDocument/2006/relationships" id="261" r:id="Rdfafb0dda9854911"/>
   </p:sldIdLst>
   <p:sldSz cx="12192000" cy="6858000"/>
   <p:notesSz cx="6858000" cy="9144000"/>
@@ -619,7 +618,7 @@
           </a:p>
           <a:p xmlns:a="http://schemas.openxmlformats.org/drawingml/2006/main">
             <a:r>
-              <a:t>Speaker cue: Why this is useful to oneCCL at first glance</a:t>
+              <a:t>Speaker cue: What the skill tells an agent today</a:t>
             </a:r>
           </a:p>
         </p:txBody>
@@ -724,7 +723,7 @@
           </a:p>
           <a:p xmlns:a="http://schemas.openxmlformats.org/drawingml/2006/main">
             <a:r>
-              <a:t>Speaker cue: What the skill tells an agent today</a:t>
+              <a:t>Speaker cue: Evaluation inventory: 5 implemented, 2 distributed gaps</a:t>
             </a:r>
           </a:p>
         </p:txBody>
@@ -829,7 +828,7 @@
           </a:p>
           <a:p xmlns:a="http://schemas.openxmlformats.org/drawingml/2006/main">
             <a:r>
-              <a:t>Speaker cue: Evaluation inventory: 5 implemented, 2 distributed gaps</a:t>
+              <a:t>Speaker cue: How we chose the content</a:t>
             </a:r>
           </a:p>
         </p:txBody>
@@ -934,7 +933,7 @@
           </a:p>
           <a:p xmlns:a="http://schemas.openxmlformats.org/drawingml/2006/main">
             <a:r>
-              <a:t>Speaker cue: How we chose the content</a:t>
+              <a:t>Speaker cue: What project ownership would look like</a:t>
             </a:r>
           </a:p>
         </p:txBody>
@@ -965,111 +964,6 @@
 </file>
 
 <file path=ppt/notesSlides/notesSlide6.xml><?xml version="1.0" encoding="utf-8"?>
-<p:notes xmlns:p="http://schemas.openxmlformats.org/presentationml/2006/main">
-  <p:cSld>
-    <p:spTree>
-      <p:nvGrpSpPr>
-        <p:cNvPr id="1" name=""/>
-        <p:cNvGrpSpPr/>
-        <p:nvPr/>
-      </p:nvGrpSpPr>
-      <p:grpSpPr>
-        <a:xfrm xmlns:a="http://schemas.openxmlformats.org/drawingml/2006/main"/>
-      </p:grpSpPr>
-      <p:sp>
-        <p:nvSpPr>
-          <p:cNvPr id="2" name="Slide Image Placeholder 1"/>
-          <p:cNvSpPr>
-            <a:spLocks xmlns:a="http://schemas.openxmlformats.org/drawingml/2006/main" noGrp="1"/>
-          </p:cNvSpPr>
-          <p:nvPr>
-            <p:ph type="sldImg" idx="0"/>
-          </p:nvPr>
-        </p:nvSpPr>
-        <p:spPr/>
-      </p:sp>
-      <p:sp>
-        <p:nvSpPr>
-          <p:cNvPr id="3" name="Notes Placeholder 2"/>
-          <p:cNvSpPr>
-            <a:spLocks xmlns:a="http://schemas.openxmlformats.org/drawingml/2006/main" noGrp="1"/>
-          </p:cNvSpPr>
-          <p:nvPr>
-            <p:ph type="body" idx="1"/>
-          </p:nvPr>
-        </p:nvSpPr>
-        <p:spPr/>
-        <p:txBody>
-          <a:bodyPr xmlns:a="http://schemas.openxmlformats.org/drawingml/2006/main"/>
-          <a:lstStyle xmlns:a="http://schemas.openxmlformats.org/drawingml/2006/main"/>
-          <a:p xmlns:a="http://schemas.openxmlformats.org/drawingml/2006/main">
-            <a:r>
-              <a:t>[Sources]</a:t>
-            </a:r>
-          </a:p>
-          <a:p xmlns:a="http://schemas.openxmlformats.org/drawingml/2006/main">
-            <a:r>
-              <a:t>- https://github.com/uxlfoundation/skills/tree/main/skills/uxl-oneccl</a:t>
-            </a:r>
-          </a:p>
-          <a:p xmlns:a="http://schemas.openxmlformats.org/drawingml/2006/main">
-            <a:r>
-              <a:t>- https://github.com/uxlfoundation/skills/blob/main/skill-cards/uxl-oneccl.md</a:t>
-            </a:r>
-          </a:p>
-          <a:p xmlns:a="http://schemas.openxmlformats.org/drawingml/2006/main">
-            <a:r>
-              <a:t>- https://github.com/uxlfoundation/skills/blob/main/evaluation/harbor/results/2026-08-27-oneccl-zero-count-fixture.md</a:t>
-            </a:r>
-          </a:p>
-          <a:p xmlns:a="http://schemas.openxmlformats.org/drawingml/2006/main">
-            <a:r>
-              <a:t>- https://github.com/uxlfoundation/skills/blob/main/evaluation/harbor/suites.json</a:t>
-            </a:r>
-          </a:p>
-          <a:p xmlns:a="http://schemas.openxmlformats.org/drawingml/2006/main">
-            <a:r>
-              <a:t>[/Sources]</a:t>
-            </a:r>
-          </a:p>
-          <a:p xmlns:a="http://schemas.openxmlformats.org/drawingml/2006/main">
-            <a:r>
-              <a:t/>
-            </a:r>
-          </a:p>
-          <a:p xmlns:a="http://schemas.openxmlformats.org/drawingml/2006/main">
-            <a:r>
-              <a:t>Speaker cue: What project ownership would look like</a:t>
-            </a:r>
-          </a:p>
-        </p:txBody>
-      </p:sp>
-      <p:sp>
-        <p:nvSpPr>
-          <p:cNvPr id="4" name="Slide Number Placeholder 3"/>
-          <p:cNvSpPr>
-            <a:spLocks xmlns:a="http://schemas.openxmlformats.org/drawingml/2006/main" noGrp="1"/>
-          </p:cNvSpPr>
-          <p:nvPr>
-            <p:ph type="sldNum" idx="5"/>
-          </p:nvPr>
-        </p:nvSpPr>
-        <p:spPr/>
-        <p:txBody>
-          <a:bodyPr xmlns:a="http://schemas.openxmlformats.org/drawingml/2006/main"/>
-          <a:lstStyle xmlns:a="http://schemas.openxmlformats.org/drawingml/2006/main"/>
-          <a:p xmlns:a="http://schemas.openxmlformats.org/drawingml/2006/main"/>
-        </p:txBody>
-      </p:sp>
-    </p:spTree>
-  </p:cSld>
-  <p:clrMapOvr>
-    <a:masterClrMapping xmlns:a="http://schemas.openxmlformats.org/drawingml/2006/main"/>
-  </p:clrMapOvr>
-</p:notes>
-</file>
-
-<file path=ppt/notesSlides/notesSlide7.xml><?xml version="1.0" encoding="utf-8"?>
 <p:notes xmlns:p="http://schemas.openxmlformats.org/presentationml/2006/main">
   <p:cSld>
     <p:spTree>
@@ -1180,7 +1074,7 @@
     <p:bg>
       <p:bgPr>
         <a:blipFill xmlns:a="http://schemas.openxmlformats.org/drawingml/2006/main">
-          <a:blip xmlns:r="http://schemas.openxmlformats.org/officeDocument/2006/relationships" r:embed="R1ed66fd0a69847be">
+          <a:blip xmlns:r="http://schemas.openxmlformats.org/officeDocument/2006/relationships" r:embed="R0fa7fd516c284d0a">
             <a:alphaModFix/>
           </a:blip>
           <a:stretch>
@@ -1615,7 +1509,7 @@
           <p:nvPr/>
         </p:nvPicPr>
         <p:blipFill rotWithShape="1">
-          <a:blip xmlns:r="http://schemas.openxmlformats.org/officeDocument/2006/relationships" xmlns:a="http://schemas.openxmlformats.org/drawingml/2006/main" r:embed="R0a6be1f029654419">
+          <a:blip xmlns:r="http://schemas.openxmlformats.org/officeDocument/2006/relationships" xmlns:a="http://schemas.openxmlformats.org/drawingml/2006/main" r:embed="R5c1903a0958a4b4e">
             <a:alphaModFix/>
           </a:blip>
           <a:srcRect xmlns:a="http://schemas.openxmlformats.org/drawingml/2006/main" l="0" t="0" r="0" b="0"/>
@@ -1645,7 +1539,7 @@
     <p:bg>
       <p:bgPr>
         <a:blipFill xmlns:a="http://schemas.openxmlformats.org/drawingml/2006/main">
-          <a:blip xmlns:r="http://schemas.openxmlformats.org/officeDocument/2006/relationships" r:embed="R35e8aebf0b104db9">
+          <a:blip xmlns:r="http://schemas.openxmlformats.org/officeDocument/2006/relationships" r:embed="R18e4cb7744ac4f30">
             <a:alphaModFix/>
           </a:blip>
           <a:stretch>
@@ -2679,7 +2573,7 @@
           <p:nvPr/>
         </p:nvPicPr>
         <p:blipFill rotWithShape="1">
-          <a:blip xmlns:r="http://schemas.openxmlformats.org/officeDocument/2006/relationships" xmlns:a="http://schemas.openxmlformats.org/drawingml/2006/main" r:embed="R0d11dd3c264d4a3e">
+          <a:blip xmlns:r="http://schemas.openxmlformats.org/officeDocument/2006/relationships" xmlns:a="http://schemas.openxmlformats.org/drawingml/2006/main" r:embed="R49274d62641c4f06">
             <a:alphaModFix/>
           </a:blip>
           <a:srcRect xmlns:a="http://schemas.openxmlformats.org/drawingml/2006/main" l="0" t="0" r="0" b="0"/>
@@ -3703,7 +3597,7 @@
           <p:nvPr/>
         </p:nvPicPr>
         <p:blipFill rotWithShape="1">
-          <a:blip xmlns:r="http://schemas.openxmlformats.org/officeDocument/2006/relationships" xmlns:a="http://schemas.openxmlformats.org/drawingml/2006/main" r:embed="R8a720f66025b4c15">
+          <a:blip xmlns:r="http://schemas.openxmlformats.org/officeDocument/2006/relationships" xmlns:a="http://schemas.openxmlformats.org/drawingml/2006/main" r:embed="Rb06982f7fb454e72">
             <a:alphaModFix/>
           </a:blip>
           <a:srcRect xmlns:a="http://schemas.openxmlformats.org/drawingml/2006/main" l="0" t="0" r="0" b="0"/>
@@ -3733,7 +3627,7 @@
     <p:bg>
       <p:bgPr>
         <a:blipFill xmlns:a="http://schemas.openxmlformats.org/drawingml/2006/main">
-          <a:blip xmlns:r="http://schemas.openxmlformats.org/officeDocument/2006/relationships" r:embed="Rd0855cef7158487f">
+          <a:blip xmlns:r="http://schemas.openxmlformats.org/officeDocument/2006/relationships" r:embed="R226dd13fd4024685">
             <a:alphaModFix/>
           </a:blip>
           <a:stretch>
@@ -5007,7 +4901,7 @@
           <p:nvPr/>
         </p:nvPicPr>
         <p:blipFill rotWithShape="1">
-          <a:blip xmlns:r="http://schemas.openxmlformats.org/officeDocument/2006/relationships" xmlns:a="http://schemas.openxmlformats.org/drawingml/2006/main" r:embed="R0e93b3764f7c4cad">
+          <a:blip xmlns:r="http://schemas.openxmlformats.org/officeDocument/2006/relationships" xmlns:a="http://schemas.openxmlformats.org/drawingml/2006/main" r:embed="R4ff978f10eca4088">
             <a:alphaModFix/>
           </a:blip>
           <a:srcRect xmlns:a="http://schemas.openxmlformats.org/drawingml/2006/main" l="0" t="0" r="0" b="0"/>
@@ -8251,7 +8145,7 @@
           <p:nvPr/>
         </p:nvPicPr>
         <p:blipFill rotWithShape="1">
-          <a:blip xmlns:r="http://schemas.openxmlformats.org/officeDocument/2006/relationships" xmlns:a="http://schemas.openxmlformats.org/drawingml/2006/main" r:embed="Re7d41a51a3964723">
+          <a:blip xmlns:r="http://schemas.openxmlformats.org/officeDocument/2006/relationships" xmlns:a="http://schemas.openxmlformats.org/drawingml/2006/main" r:embed="R1236982942504250">
             <a:alphaModFix/>
           </a:blip>
           <a:srcRect xmlns:a="http://schemas.openxmlformats.org/drawingml/2006/main" l="0" t="0" r="0" b="0"/>
@@ -9989,7 +9883,7 @@
           <p:nvPr/>
         </p:nvPicPr>
         <p:blipFill rotWithShape="1">
-          <a:blip xmlns:r="http://schemas.openxmlformats.org/officeDocument/2006/relationships" xmlns:a="http://schemas.openxmlformats.org/drawingml/2006/main" r:embed="R0e9c0a1b65504a25">
+          <a:blip xmlns:r="http://schemas.openxmlformats.org/officeDocument/2006/relationships" xmlns:a="http://schemas.openxmlformats.org/drawingml/2006/main" r:embed="Rff5b327dc46c43b3">
             <a:alphaModFix/>
           </a:blip>
           <a:srcRect xmlns:a="http://schemas.openxmlformats.org/drawingml/2006/main" l="0" t="0" r="0" b="0"/>
@@ -16818,7 +16712,7 @@
     <p:bg>
       <p:bgPr>
         <a:blipFill xmlns:a="http://schemas.openxmlformats.org/drawingml/2006/main">
-          <a:blip xmlns:r="http://schemas.openxmlformats.org/officeDocument/2006/relationships" r:embed="Ra2ddb1c370bb4f2b">
+          <a:blip xmlns:r="http://schemas.openxmlformats.org/officeDocument/2006/relationships" r:embed="R1780b706b99f4fe5">
             <a:alphaModFix/>
           </a:blip>
           <a:stretch>
@@ -17253,7 +17147,7 @@
           <p:nvPr/>
         </p:nvPicPr>
         <p:blipFill rotWithShape="1">
-          <a:blip xmlns:r="http://schemas.openxmlformats.org/officeDocument/2006/relationships" xmlns:a="http://schemas.openxmlformats.org/drawingml/2006/main" r:embed="R4212a50cadfa4c26">
+          <a:blip xmlns:r="http://schemas.openxmlformats.org/officeDocument/2006/relationships" xmlns:a="http://schemas.openxmlformats.org/drawingml/2006/main" r:embed="Rdd37442a9e8940a6">
             <a:alphaModFix/>
           </a:blip>
           <a:srcRect xmlns:a="http://schemas.openxmlformats.org/drawingml/2006/main" l="0" t="0" r="0" b="0"/>
@@ -17283,7 +17177,7 @@
     <p:bg>
       <p:bgPr>
         <a:blipFill xmlns:a="http://schemas.openxmlformats.org/drawingml/2006/main">
-          <a:blip xmlns:r="http://schemas.openxmlformats.org/officeDocument/2006/relationships" r:embed="R4eae026f2a304686">
+          <a:blip xmlns:r="http://schemas.openxmlformats.org/officeDocument/2006/relationships" r:embed="R2f4e6ebb8454423a">
             <a:alphaModFix/>
           </a:blip>
           <a:stretch>
@@ -17916,7 +17810,7 @@
           <p:nvPr/>
         </p:nvPicPr>
         <p:blipFill rotWithShape="1">
-          <a:blip xmlns:r="http://schemas.openxmlformats.org/officeDocument/2006/relationships" xmlns:a="http://schemas.openxmlformats.org/drawingml/2006/main" r:embed="R57cc49e7e2314785">
+          <a:blip xmlns:r="http://schemas.openxmlformats.org/officeDocument/2006/relationships" xmlns:a="http://schemas.openxmlformats.org/drawingml/2006/main" r:embed="R85e6aa761cb34980">
             <a:alphaModFix/>
           </a:blip>
           <a:srcRect xmlns:a="http://schemas.openxmlformats.org/drawingml/2006/main" l="0" t="0" r="0" b="0"/>
@@ -18376,7 +18270,7 @@
     <p:bg>
       <p:bgPr>
         <a:blipFill xmlns:a="http://schemas.openxmlformats.org/drawingml/2006/main">
-          <a:blip xmlns:r="http://schemas.openxmlformats.org/officeDocument/2006/relationships" r:embed="R2ae732db6c9e450f">
+          <a:blip xmlns:r="http://schemas.openxmlformats.org/officeDocument/2006/relationships" r:embed="Ree0cb5b201094d84">
             <a:alphaModFix/>
           </a:blip>
           <a:stretch>
@@ -19009,7 +18903,7 @@
           <p:nvPr/>
         </p:nvPicPr>
         <p:blipFill rotWithShape="1">
-          <a:blip xmlns:r="http://schemas.openxmlformats.org/officeDocument/2006/relationships" xmlns:a="http://schemas.openxmlformats.org/drawingml/2006/main" r:embed="Rd4ec2480967b4fff">
+          <a:blip xmlns:r="http://schemas.openxmlformats.org/officeDocument/2006/relationships" xmlns:a="http://schemas.openxmlformats.org/drawingml/2006/main" r:embed="Rf70c23b3cd3d4052">
             <a:alphaModFix/>
           </a:blip>
           <a:srcRect xmlns:a="http://schemas.openxmlformats.org/drawingml/2006/main" l="0" t="0" r="0" b="0"/>
@@ -21665,7 +21559,7 @@
           <p:nvPr/>
         </p:nvPicPr>
         <p:blipFill rotWithShape="1">
-          <a:blip xmlns:r="http://schemas.openxmlformats.org/officeDocument/2006/relationships" xmlns:a="http://schemas.openxmlformats.org/drawingml/2006/main" r:embed="Rf55012417bb64b6d">
+          <a:blip xmlns:r="http://schemas.openxmlformats.org/officeDocument/2006/relationships" xmlns:a="http://schemas.openxmlformats.org/drawingml/2006/main" r:embed="R28070925d1074bb4">
             <a:alphaModFix/>
           </a:blip>
           <a:srcRect xmlns:a="http://schemas.openxmlformats.org/drawingml/2006/main" l="0" t="0" r="0" b="0"/>
@@ -21695,7 +21589,7 @@
     <p:bg>
       <p:bgPr>
         <a:blipFill xmlns:a="http://schemas.openxmlformats.org/drawingml/2006/main">
-          <a:blip xmlns:r="http://schemas.openxmlformats.org/officeDocument/2006/relationships" r:embed="Rdb645905176643a3">
+          <a:blip xmlns:r="http://schemas.openxmlformats.org/officeDocument/2006/relationships" r:embed="R9e0e8be0ee984e55">
             <a:alphaModFix/>
           </a:blip>
           <a:stretch>
@@ -22539,7 +22433,7 @@
           <p:nvPr/>
         </p:nvPicPr>
         <p:blipFill rotWithShape="1">
-          <a:blip xmlns:r="http://schemas.openxmlformats.org/officeDocument/2006/relationships" xmlns:a="http://schemas.openxmlformats.org/drawingml/2006/main" r:embed="Rd540fa12077944d9">
+          <a:blip xmlns:r="http://schemas.openxmlformats.org/officeDocument/2006/relationships" xmlns:a="http://schemas.openxmlformats.org/drawingml/2006/main" r:embed="R658cc3de10f24f1d">
             <a:alphaModFix/>
           </a:blip>
           <a:srcRect xmlns:a="http://schemas.openxmlformats.org/drawingml/2006/main" l="0" t="0" r="0" b="0"/>
@@ -22569,7 +22463,7 @@
     <p:bg>
       <p:bgPr>
         <a:blipFill xmlns:a="http://schemas.openxmlformats.org/drawingml/2006/main">
-          <a:blip xmlns:r="http://schemas.openxmlformats.org/officeDocument/2006/relationships" r:embed="Rf8b43fe2c9134d6e">
+          <a:blip xmlns:r="http://schemas.openxmlformats.org/officeDocument/2006/relationships" r:embed="R7e87af6f4871491c">
             <a:alphaModFix/>
           </a:blip>
           <a:stretch>
@@ -23517,7 +23411,7 @@
           <p:nvPr/>
         </p:nvPicPr>
         <p:blipFill rotWithShape="1">
-          <a:blip xmlns:r="http://schemas.openxmlformats.org/officeDocument/2006/relationships" xmlns:a="http://schemas.openxmlformats.org/drawingml/2006/main" r:embed="Rb4a68ce645964524">
+          <a:blip xmlns:r="http://schemas.openxmlformats.org/officeDocument/2006/relationships" xmlns:a="http://schemas.openxmlformats.org/drawingml/2006/main" r:embed="R53de99c2ca2c4b97">
             <a:alphaModFix/>
           </a:blip>
           <a:srcRect xmlns:a="http://schemas.openxmlformats.org/drawingml/2006/main" l="0" t="0" r="0" b="0"/>
@@ -23547,7 +23441,7 @@
     <p:bg>
       <p:bgPr>
         <a:blipFill xmlns:a="http://schemas.openxmlformats.org/drawingml/2006/main">
-          <a:blip xmlns:r="http://schemas.openxmlformats.org/officeDocument/2006/relationships" r:embed="Ra5e15cb289e54e68">
+          <a:blip xmlns:r="http://schemas.openxmlformats.org/officeDocument/2006/relationships" r:embed="R0c934d4d3daa4765">
             <a:alphaModFix/>
           </a:blip>
           <a:stretch>
@@ -24008,7 +23902,7 @@
           <p:nvPr/>
         </p:nvPicPr>
         <p:blipFill rotWithShape="1">
-          <a:blip xmlns:r="http://schemas.openxmlformats.org/officeDocument/2006/relationships" xmlns:a="http://schemas.openxmlformats.org/drawingml/2006/main" r:embed="Rf5c0d477b2cf4609">
+          <a:blip xmlns:r="http://schemas.openxmlformats.org/officeDocument/2006/relationships" xmlns:a="http://schemas.openxmlformats.org/drawingml/2006/main" r:embed="Rbe4960775d5243ae">
             <a:alphaModFix/>
           </a:blip>
           <a:srcRect xmlns:a="http://schemas.openxmlformats.org/drawingml/2006/main" l="0" t="0" r="0" b="0"/>
@@ -25720,22 +25614,22 @@
   </p:cSld>
   <p:clrMap bg1="lt1" tx1="dk1" bg2="dk2" tx2="lt2" accent1="accent1" accent2="accent2" accent3="accent3" accent4="accent4" accent5="accent5" accent6="accent6" hlink="hlink" folHlink="folHlink"/>
   <p:sldLayoutIdLst>
-    <p:sldLayoutId xmlns:r="http://schemas.openxmlformats.org/officeDocument/2006/relationships" id="2147483649" r:id="R97621fdecee04ae0"/>
-    <p:sldLayoutId xmlns:r="http://schemas.openxmlformats.org/officeDocument/2006/relationships" id="2147483650" r:id="R114f20e322384388"/>
-    <p:sldLayoutId xmlns:r="http://schemas.openxmlformats.org/officeDocument/2006/relationships" id="2147483651" r:id="Rfc13bfd126a9484f"/>
-    <p:sldLayoutId xmlns:r="http://schemas.openxmlformats.org/officeDocument/2006/relationships" id="2147483652" r:id="R0d7ba0b0de1041d8"/>
-    <p:sldLayoutId xmlns:r="http://schemas.openxmlformats.org/officeDocument/2006/relationships" id="2147483653" r:id="R1be8d60a68f2414d"/>
-    <p:sldLayoutId xmlns:r="http://schemas.openxmlformats.org/officeDocument/2006/relationships" id="2147483654" r:id="R45271084f6db4711"/>
-    <p:sldLayoutId xmlns:r="http://schemas.openxmlformats.org/officeDocument/2006/relationships" id="2147483655" r:id="R174499768e9a4dd6"/>
-    <p:sldLayoutId xmlns:r="http://schemas.openxmlformats.org/officeDocument/2006/relationships" id="2147483656" r:id="Rdc1f05025fd74ce4"/>
-    <p:sldLayoutId xmlns:r="http://schemas.openxmlformats.org/officeDocument/2006/relationships" id="2147483657" r:id="R121156b0ae8e4a71"/>
-    <p:sldLayoutId xmlns:r="http://schemas.openxmlformats.org/officeDocument/2006/relationships" id="2147483658" r:id="Rf08b5320ef2b4287"/>
-    <p:sldLayoutId xmlns:r="http://schemas.openxmlformats.org/officeDocument/2006/relationships" id="2147483659" r:id="R121fc4b47a80419d"/>
-    <p:sldLayoutId xmlns:r="http://schemas.openxmlformats.org/officeDocument/2006/relationships" id="2147483660" r:id="Rf16579a443df4bf7"/>
-    <p:sldLayoutId xmlns:r="http://schemas.openxmlformats.org/officeDocument/2006/relationships" id="2147483661" r:id="Rd860cce5811f444a"/>
-    <p:sldLayoutId xmlns:r="http://schemas.openxmlformats.org/officeDocument/2006/relationships" id="2147483662" r:id="R684c7644e7014d9e"/>
-    <p:sldLayoutId xmlns:r="http://schemas.openxmlformats.org/officeDocument/2006/relationships" id="2147483663" r:id="Rd80c69d94afc4e60"/>
-    <p:sldLayoutId xmlns:r="http://schemas.openxmlformats.org/officeDocument/2006/relationships" id="2147483664" r:id="Ra1fd0a7d875c48d5"/>
+    <p:sldLayoutId xmlns:r="http://schemas.openxmlformats.org/officeDocument/2006/relationships" id="2147483649" r:id="R799ede6a78be464f"/>
+    <p:sldLayoutId xmlns:r="http://schemas.openxmlformats.org/officeDocument/2006/relationships" id="2147483650" r:id="R73d8f3143b344c8b"/>
+    <p:sldLayoutId xmlns:r="http://schemas.openxmlformats.org/officeDocument/2006/relationships" id="2147483651" r:id="R8af6d623281a44bc"/>
+    <p:sldLayoutId xmlns:r="http://schemas.openxmlformats.org/officeDocument/2006/relationships" id="2147483652" r:id="Rd1abece36e67438b"/>
+    <p:sldLayoutId xmlns:r="http://schemas.openxmlformats.org/officeDocument/2006/relationships" id="2147483653" r:id="R12a5d0a2882147df"/>
+    <p:sldLayoutId xmlns:r="http://schemas.openxmlformats.org/officeDocument/2006/relationships" id="2147483654" r:id="R3b23b859f5714009"/>
+    <p:sldLayoutId xmlns:r="http://schemas.openxmlformats.org/officeDocument/2006/relationships" id="2147483655" r:id="Rb348f389456a47a7"/>
+    <p:sldLayoutId xmlns:r="http://schemas.openxmlformats.org/officeDocument/2006/relationships" id="2147483656" r:id="Rf72c8454f50042d7"/>
+    <p:sldLayoutId xmlns:r="http://schemas.openxmlformats.org/officeDocument/2006/relationships" id="2147483657" r:id="Rdb6fd195298f4cfe"/>
+    <p:sldLayoutId xmlns:r="http://schemas.openxmlformats.org/officeDocument/2006/relationships" id="2147483658" r:id="Red9b92bc49e949f7"/>
+    <p:sldLayoutId xmlns:r="http://schemas.openxmlformats.org/officeDocument/2006/relationships" id="2147483659" r:id="Rc13890a80f4a4e9e"/>
+    <p:sldLayoutId xmlns:r="http://schemas.openxmlformats.org/officeDocument/2006/relationships" id="2147483660" r:id="Rb9ace67daa914406"/>
+    <p:sldLayoutId xmlns:r="http://schemas.openxmlformats.org/officeDocument/2006/relationships" id="2147483661" r:id="R393c0f8286b54c3c"/>
+    <p:sldLayoutId xmlns:r="http://schemas.openxmlformats.org/officeDocument/2006/relationships" id="2147483662" r:id="R01a1ba7f9fdb419b"/>
+    <p:sldLayoutId xmlns:r="http://schemas.openxmlformats.org/officeDocument/2006/relationships" id="2147483663" r:id="R722863ce344f410d"/>
+    <p:sldLayoutId xmlns:r="http://schemas.openxmlformats.org/officeDocument/2006/relationships" id="2147483664" r:id="Rc068b8e95221435a"/>
   </p:sldLayoutIdLst>
   <p:hf hdr="0" ftr="0" dt="0"/>
   <p:txStyles>
@@ -27928,7 +27822,7 @@
           <p:nvPr/>
         </p:nvPicPr>
         <p:blipFill rotWithShape="1">
-          <a:blip xmlns:r="http://schemas.openxmlformats.org/officeDocument/2006/relationships" xmlns:a="http://schemas.openxmlformats.org/drawingml/2006/main" r:embed="Rb9047647672d46b2">
+          <a:blip xmlns:r="http://schemas.openxmlformats.org/officeDocument/2006/relationships" xmlns:a="http://schemas.openxmlformats.org/drawingml/2006/main" r:embed="R8fbeb4e15b40427e">
             <a:alphaModFix/>
           </a:blip>
           <a:srcRect xmlns:a="http://schemas.openxmlformats.org/drawingml/2006/main" l="0" t="0" r="0" b="0"/>
@@ -27951,19 +27845,19 @@
   </p:cSld>
   <p:clrMap bg1="lt1" tx1="dk1" bg2="dk2" tx2="lt2" accent1="accent1" accent2="accent2" accent3="accent3" accent4="accent4" accent5="accent5" accent6="accent6" hlink="hlink" folHlink="folHlink"/>
   <p:sldLayoutIdLst>
-    <p:sldLayoutId xmlns:r="http://schemas.openxmlformats.org/officeDocument/2006/relationships" id="2147483666" r:id="Rae0e9029b0fe425e"/>
-    <p:sldLayoutId xmlns:r="http://schemas.openxmlformats.org/officeDocument/2006/relationships" id="2147483667" r:id="R16c9b81c4be944ec"/>
-    <p:sldLayoutId xmlns:r="http://schemas.openxmlformats.org/officeDocument/2006/relationships" id="2147483668" r:id="Re4fd9f31b62a432f"/>
-    <p:sldLayoutId xmlns:r="http://schemas.openxmlformats.org/officeDocument/2006/relationships" id="2147483669" r:id="R5e7cd2e49e3e43fa"/>
-    <p:sldLayoutId xmlns:r="http://schemas.openxmlformats.org/officeDocument/2006/relationships" id="2147483670" r:id="R0b46da66d5d84e40"/>
-    <p:sldLayoutId xmlns:r="http://schemas.openxmlformats.org/officeDocument/2006/relationships" id="2147483671" r:id="Rc1c07383c90b4fc3"/>
-    <p:sldLayoutId xmlns:r="http://schemas.openxmlformats.org/officeDocument/2006/relationships" id="2147483672" r:id="R78b6cd39d3c248f6"/>
-    <p:sldLayoutId xmlns:r="http://schemas.openxmlformats.org/officeDocument/2006/relationships" id="2147483673" r:id="R25b89b10a0004e4c"/>
-    <p:sldLayoutId xmlns:r="http://schemas.openxmlformats.org/officeDocument/2006/relationships" id="2147483674" r:id="Re91be48614c74292"/>
-    <p:sldLayoutId xmlns:r="http://schemas.openxmlformats.org/officeDocument/2006/relationships" id="2147483675" r:id="R56a0f04e255c4466"/>
-    <p:sldLayoutId xmlns:r="http://schemas.openxmlformats.org/officeDocument/2006/relationships" id="2147483676" r:id="R9c12d29beb7b489f"/>
-    <p:sldLayoutId xmlns:r="http://schemas.openxmlformats.org/officeDocument/2006/relationships" id="2147483677" r:id="Reca442d49c2148f2"/>
-    <p:sldLayoutId xmlns:r="http://schemas.openxmlformats.org/officeDocument/2006/relationships" id="2147483678" r:id="R4f3d92b35f574566"/>
+    <p:sldLayoutId xmlns:r="http://schemas.openxmlformats.org/officeDocument/2006/relationships" id="2147483666" r:id="R92b7f82a91ca4051"/>
+    <p:sldLayoutId xmlns:r="http://schemas.openxmlformats.org/officeDocument/2006/relationships" id="2147483667" r:id="Rb9b89e204d3d4dcd"/>
+    <p:sldLayoutId xmlns:r="http://schemas.openxmlformats.org/officeDocument/2006/relationships" id="2147483668" r:id="Ra905f8726b27453d"/>
+    <p:sldLayoutId xmlns:r="http://schemas.openxmlformats.org/officeDocument/2006/relationships" id="2147483669" r:id="Rc637ba30ef91406d"/>
+    <p:sldLayoutId xmlns:r="http://schemas.openxmlformats.org/officeDocument/2006/relationships" id="2147483670" r:id="Rda8cd8fcb1cb4a09"/>
+    <p:sldLayoutId xmlns:r="http://schemas.openxmlformats.org/officeDocument/2006/relationships" id="2147483671" r:id="Racdabfdcadad4dac"/>
+    <p:sldLayoutId xmlns:r="http://schemas.openxmlformats.org/officeDocument/2006/relationships" id="2147483672" r:id="R20164493139e46d2"/>
+    <p:sldLayoutId xmlns:r="http://schemas.openxmlformats.org/officeDocument/2006/relationships" id="2147483673" r:id="R6d929edbf50d4c7d"/>
+    <p:sldLayoutId xmlns:r="http://schemas.openxmlformats.org/officeDocument/2006/relationships" id="2147483674" r:id="R6738698598584d79"/>
+    <p:sldLayoutId xmlns:r="http://schemas.openxmlformats.org/officeDocument/2006/relationships" id="2147483675" r:id="Rbc066c5e8da846ee"/>
+    <p:sldLayoutId xmlns:r="http://schemas.openxmlformats.org/officeDocument/2006/relationships" id="2147483676" r:id="R5ce7ad7961b34f24"/>
+    <p:sldLayoutId xmlns:r="http://schemas.openxmlformats.org/officeDocument/2006/relationships" id="2147483677" r:id="R7f1ffd43371048a8"/>
+    <p:sldLayoutId xmlns:r="http://schemas.openxmlformats.org/officeDocument/2006/relationships" id="2147483678" r:id="Rbd2be75ccd5a41fc"/>
   </p:sldLayoutIdLst>
   <p:hf hdr="0" ftr="0" dt="0"/>
   <p:txStyles>
@@ -29368,7 +29262,7 @@
           <a:lstStyle xmlns:a="http://schemas.openxmlformats.org/drawingml/2006/main"/>
           <a:p xmlns:a="http://schemas.openxmlformats.org/drawingml/2006/main">
             <a:r>
-              <a:t>Why this is useful to oneCCL at first glance</a:t>
+              <a:t>What the skill tells an agent today</a:t>
             </a:r>
           </a:p>
         </p:txBody>
@@ -29418,7 +29312,7 @@
                   <a:srgbClr val="000000"/>
                 </a:solidFill>
               </a:rPr>
-              <a:t> Prevent deadlocks before tuning</a:t>
+              <a:t> Identify the API surface</a:t>
             </a:r>
             <a:r>
               <a:rPr sz="1913">
@@ -29426,7 +29320,7 @@
                   <a:srgbClr val="000000"/>
                 </a:solidFill>
               </a:rPr>
-              <a:t> — Every rank must enter the same collective sequence with compatible buffers, counts, types, roots, and communicators.</a:t>
+              <a:t> — C++ API, NCCL-like C API, PyTorch DDP, Horovod, or framework wrapper.</a:t>
             </a:r>
           </a:p>
           <a:p xmlns:a="http://schemas.openxmlformats.org/drawingml/2006/main">
@@ -29447,7 +29341,7 @@
                   <a:srgbClr val="000000"/>
                 </a:solidFill>
               </a:rPr>
-              <a:t> Make async completion explicit</a:t>
+              <a:t> Match collective to semantics</a:t>
             </a:r>
             <a:r>
               <a:rPr sz="1913">
@@ -29455,7 +29349,7 @@
                   <a:srgbClr val="000000"/>
                 </a:solidFill>
               </a:rPr>
-              <a:t> — A submitted collective is not complete until waited or otherwise synchronized.</a:t>
+              <a:t> — Allreduce, allgather, alltoall, reduce-scatter, broadcast, point-to-point, or grouped calls.</a:t>
             </a:r>
           </a:p>
           <a:p xmlns:a="http://schemas.openxmlformats.org/drawingml/2006/main">
@@ -29476,7 +29370,7 @@
                   <a:srgbClr val="000000"/>
                 </a:solidFill>
               </a:rPr>
-              <a:t> Collect evidence per rank</a:t>
+              <a:t> Validate rank symmetry</a:t>
             </a:r>
             <a:r>
               <a:rPr sz="1913">
@@ -29484,7 +29378,7 @@
                   <a:srgbClr val="000000"/>
                 </a:solidFill>
               </a:rPr>
-              <a:t> — Launch command, mapping, plugin, transport, environment, entry/submission/wait logs, and minimal reproducer.</a:t>
+              <a:t> — Collective order, buffer sizes, datatypes, roots, reductions, and communicator membership.</a:t>
             </a:r>
           </a:p>
           <a:p xmlns:a="http://schemas.openxmlformats.org/drawingml/2006/main">
@@ -29505,7 +29399,7 @@
                   <a:srgbClr val="000000"/>
                 </a:solidFill>
               </a:rPr>
-              <a:t> Separate correctness from transport tuning</a:t>
+              <a:t> Handle zero counts safely</a:t>
             </a:r>
             <a:r>
               <a:rPr sz="1913">
@@ -29513,7 +29407,36 @@
                   <a:srgbClr val="000000"/>
                 </a:solidFill>
               </a:rPr>
-              <a:t> — Worker count, affinity, plugin, and transport change only after launch symmetry is proven.</a:t>
+              <a:t> — Represent empty peer segments without one-past device pointers, including in-place temporaries.</a:t>
+            </a:r>
+          </a:p>
+          <a:p xmlns:a="http://schemas.openxmlformats.org/drawingml/2006/main">
+            <a:pPr marL="30" indent="-18">
+              <a:spcAft>
+                <a:spcPts val="10"/>
+              </a:spcAft>
+              <a:buChar char="•"/>
+              <a:defRPr sz="1913">
+                <a:solidFill>
+                  <a:srgbClr val="000000"/>
+                </a:solidFill>
+              </a:defRPr>
+            </a:pPr>
+            <a:r>
+              <a:rPr sz="1913" b="1">
+                <a:solidFill>
+                  <a:srgbClr val="000000"/>
+                </a:solidFill>
+              </a:rPr>
+              <a:t> Reduce hangs deliberately</a:t>
+            </a:r>
+            <a:r>
+              <a:rPr sz="1913">
+                <a:solidFill>
+                  <a:srgbClr val="000000"/>
+                </a:solidFill>
+              </a:rPr>
+              <a:t> — Two ranks, one small tensor, one collective, and logs around entry/submission/wait.</a:t>
             </a:r>
           </a:p>
         </p:txBody>
@@ -29605,7 +29528,7 @@
           <a:lstStyle xmlns:a="http://schemas.openxmlformats.org/drawingml/2006/main"/>
           <a:p xmlns:a="http://schemas.openxmlformats.org/drawingml/2006/main">
             <a:r>
-              <a:t>What the skill tells an agent today</a:t>
+              <a:t>Evaluation inventory: 5 implemented, 2 distributed gaps</a:t>
             </a:r>
           </a:p>
         </p:txBody>
@@ -29655,7 +29578,7 @@
                   <a:srgbClr val="000000"/>
                 </a:solidFill>
               </a:rPr>
-              <a:t> Identify the API surface</a:t>
+              <a:t> Implemented</a:t>
             </a:r>
             <a:r>
               <a:rPr sz="1913">
@@ -29663,7 +29586,7 @@
                   <a:srgbClr val="000000"/>
                 </a:solidFill>
               </a:rPr>
-              <a:t> — C++ API, NCCL-like C API, PyTorch DDP, Horovod, or framework wrapper.</a:t>
+              <a:t> — Async allreduce wait; divergent collective sequence; datatype/count mismatch; C++ versus NCCL-like API; zero-count topo alltoallv.</a:t>
             </a:r>
           </a:p>
           <a:p xmlns:a="http://schemas.openxmlformats.org/drawingml/2006/main">
@@ -29684,7 +29607,7 @@
                   <a:srgbClr val="000000"/>
                 </a:solidFill>
               </a:rPr>
-              <a:t> Match collective to semantics</a:t>
+              <a:t> Incident evidence</a:t>
             </a:r>
             <a:r>
               <a:rPr sz="1913">
@@ -29692,7 +29615,7 @@
                   <a:srgbClr val="000000"/>
                 </a:solidFill>
               </a:rPr>
-              <a:t> — Allreduce, allgather, alltoall, reduce-scatter, broadcast, point-to-point, or grouped calls.</a:t>
+              <a:t> — The zero-count task checks the accepted repair boundary from upstream issue #174.</a:t>
             </a:r>
           </a:p>
           <a:p xmlns:a="http://schemas.openxmlformats.org/drawingml/2006/main">
@@ -29713,7 +29636,7 @@
                   <a:srgbClr val="000000"/>
                 </a:solidFill>
               </a:rPr>
-              <a:t> Validate rank symmetry</a:t>
+              <a:t> Planned</a:t>
             </a:r>
             <a:r>
               <a:rPr sz="1913">
@@ -29721,7 +29644,7 @@
                   <a:srgbClr val="000000"/>
                 </a:solidFill>
               </a:rPr>
-              <a:t> — Collective order, buffer sizes, datatypes, roots, reductions, and communicator membership.</a:t>
+              <a:t> — Plugin rank visibility and worker-affinity regression on a stable distributed target.</a:t>
             </a:r>
           </a:p>
           <a:p xmlns:a="http://schemas.openxmlformats.org/drawingml/2006/main">
@@ -29742,7 +29665,7 @@
                   <a:srgbClr val="000000"/>
                 </a:solidFill>
               </a:rPr>
-              <a:t> Handle zero counts safely</a:t>
+              <a:t> Evidence boundary</a:t>
             </a:r>
             <a:r>
               <a:rPr sz="1913">
@@ -29750,36 +29673,7 @@
                   <a:srgbClr val="000000"/>
                 </a:solidFill>
               </a:rPr>
-              <a:t> — Represent empty peer segments without one-past device pointers, including in-place temporaries.</a:t>
-            </a:r>
-          </a:p>
-          <a:p xmlns:a="http://schemas.openxmlformats.org/drawingml/2006/main">
-            <a:pPr marL="30" indent="-18">
-              <a:spcAft>
-                <a:spcPts val="10"/>
-              </a:spcAft>
-              <a:buChar char="•"/>
-              <a:defRPr sz="1913">
-                <a:solidFill>
-                  <a:srgbClr val="000000"/>
-                </a:solidFill>
-              </a:defRPr>
-            </a:pPr>
-            <a:r>
-              <a:rPr sz="1913" b="1">
-                <a:solidFill>
-                  <a:srgbClr val="000000"/>
-                </a:solidFill>
-              </a:rPr>
-              <a:t> Reduce hangs deliberately</a:t>
-            </a:r>
-            <a:r>
-              <a:rPr sz="1913">
-                <a:solidFill>
-                  <a:srgbClr val="000000"/>
-                </a:solidFill>
-              </a:rPr>
-              <a:t> — Two ranks, one small tensor, one collective, and logs around entry/submission/wait.</a:t>
+              <a:t> — The current fixture does not reproduce the original Aurora/Level Zero failure and must not be presented as hardware qualification.</a:t>
             </a:r>
           </a:p>
         </p:txBody>
@@ -29871,7 +29765,7 @@
           <a:lstStyle xmlns:a="http://schemas.openxmlformats.org/drawingml/2006/main"/>
           <a:p xmlns:a="http://schemas.openxmlformats.org/drawingml/2006/main">
             <a:r>
-              <a:t>Evaluation inventory: 5 implemented, 2 distributed gaps</a:t>
+              <a:t>How we chose the content</a:t>
             </a:r>
           </a:p>
         </p:txBody>
@@ -29921,7 +29815,7 @@
                   <a:srgbClr val="000000"/>
                 </a:solidFill>
               </a:rPr>
-              <a:t> Implemented</a:t>
+              <a:t> Official sources</a:t>
             </a:r>
             <a:r>
               <a:rPr sz="1913">
@@ -29929,7 +29823,7 @@
                   <a:srgbClr val="000000"/>
                 </a:solidFill>
               </a:rPr>
-              <a:t> — Async allreduce wait; divergent collective sequence; datatype/count mismatch; C++ versus NCCL-like API; zero-count topo alltoallv.</a:t>
+              <a:t> — Project docs, examples, launch guidance, plugins, integrations, releases, and issue evidence.</a:t>
             </a:r>
           </a:p>
           <a:p xmlns:a="http://schemas.openxmlformats.org/drawingml/2006/main">
@@ -29950,7 +29844,7 @@
                   <a:srgbClr val="000000"/>
                 </a:solidFill>
               </a:rPr>
-              <a:t> Incident evidence</a:t>
+              <a:t> Common distributed failure structure</a:t>
             </a:r>
             <a:r>
               <a:rPr sz="1913">
@@ -29958,7 +29852,7 @@
                   <a:srgbClr val="000000"/>
                 </a:solidFill>
               </a:rPr>
-              <a:t> — The zero-count task checks the accepted repair boundary from upstream issue #174.</a:t>
+              <a:t> — Asymmetric calls, waits, buffer/count mismatches, rank mapping, plugin visibility, and hidden framework collectives.</a:t>
             </a:r>
           </a:p>
           <a:p xmlns:a="http://schemas.openxmlformats.org/drawingml/2006/main">
@@ -29979,7 +29873,7 @@
                   <a:srgbClr val="000000"/>
                 </a:solidFill>
               </a:rPr>
-              <a:t> Planned</a:t>
+              <a:t> Minimal executable tasks</a:t>
             </a:r>
             <a:r>
               <a:rPr sz="1913">
@@ -29987,7 +29881,7 @@
                   <a:srgbClr val="000000"/>
                 </a:solidFill>
               </a:rPr>
-              <a:t> — Plugin rank visibility and worker-affinity regression on a stable distributed target.</a:t>
+              <a:t> — Hosted fixtures check reasoning and repair contracts where real multi-rank hardware is not required.</a:t>
             </a:r>
           </a:p>
           <a:p xmlns:a="http://schemas.openxmlformats.org/drawingml/2006/main">
@@ -30008,7 +29902,7 @@
                   <a:srgbClr val="000000"/>
                 </a:solidFill>
               </a:rPr>
-              <a:t> Evidence boundary</a:t>
+              <a:t> Visible infrastructure gaps</a:t>
             </a:r>
             <a:r>
               <a:rPr sz="1913">
@@ -30016,7 +29910,7 @@
                   <a:srgbClr val="000000"/>
                 </a:solidFill>
               </a:rPr>
-              <a:t> — The current fixture does not reproduce the original Aurora/Level Zero failure and must not be presented as hardware qualification.</a:t>
+              <a:t> — Distributed plugin and affinity work stays planned until a faithful lane and provenance exist.</a:t>
             </a:r>
           </a:p>
         </p:txBody>
@@ -30108,7 +30002,7 @@
           <a:lstStyle xmlns:a="http://schemas.openxmlformats.org/drawingml/2006/main"/>
           <a:p xmlns:a="http://schemas.openxmlformats.org/drawingml/2006/main">
             <a:r>
-              <a:t>How we chose the content</a:t>
+              <a:t>What project ownership would look like</a:t>
             </a:r>
           </a:p>
         </p:txBody>
@@ -30158,7 +30052,7 @@
                   <a:srgbClr val="000000"/>
                 </a:solidFill>
               </a:rPr>
-              <a:t> Official sources</a:t>
+              <a:t> Review launch and API guidance</a:t>
             </a:r>
             <a:r>
               <a:rPr sz="1913">
@@ -30166,7 +30060,7 @@
                   <a:srgbClr val="000000"/>
                 </a:solidFill>
               </a:rPr>
-              <a:t> — Project docs, examples, launch guidance, plugins, integrations, releases, and issue evidence.</a:t>
+              <a:t> — Especially current C API status, GPU/plugin behavior, framework integration, and environment conventions.</a:t>
             </a:r>
           </a:p>
           <a:p xmlns:a="http://schemas.openxmlformats.org/drawingml/2006/main">
@@ -30187,7 +30081,7 @@
                   <a:srgbClr val="000000"/>
                 </a:solidFill>
               </a:rPr>
-              <a:t> Common distributed failure structure</a:t>
+              <a:t> Validate hang-triage order</a:t>
             </a:r>
             <a:r>
               <a:rPr sz="1913">
@@ -30195,7 +30089,7 @@
                   <a:srgbClr val="000000"/>
                 </a:solidFill>
               </a:rPr>
-              <a:t> — Asymmetric calls, waits, buffer/count mismatches, rank mapping, plugin visibility, and hidden framework collectives.</a:t>
+              <a:t> — Ensure the evidence sequence matches how maintainers actually debug incidents.</a:t>
             </a:r>
           </a:p>
           <a:p xmlns:a="http://schemas.openxmlformats.org/drawingml/2006/main">
@@ -30216,7 +30110,7 @@
                   <a:srgbClr val="000000"/>
                 </a:solidFill>
               </a:rPr>
-              <a:t> Minimal executable tasks</a:t>
+              <a:t> Supply authentic distributed cases</a:t>
             </a:r>
             <a:r>
               <a:rPr sz="1913">
@@ -30224,7 +30118,7 @@
                   <a:srgbClr val="000000"/>
                 </a:solidFill>
               </a:rPr>
-              <a:t> — Hosted fixtures check reasoning and repair contracts where real multi-rank hardware is not required.</a:t>
+              <a:t> — The highest-value next step is a reproducible plugin or rank-visibility incident.</a:t>
             </a:r>
           </a:p>
           <a:p xmlns:a="http://schemas.openxmlformats.org/drawingml/2006/main">
@@ -30245,7 +30139,7 @@
                   <a:srgbClr val="000000"/>
                 </a:solidFill>
               </a:rPr>
-              <a:t> Visible infrastructure gaps</a:t>
+              <a:t> UXL keeps the machinery</a:t>
             </a:r>
             <a:r>
               <a:rPr sz="1913">
@@ -30253,7 +30147,7 @@
                   <a:srgbClr val="000000"/>
                 </a:solidFill>
               </a:rPr>
-              <a:t> — Distributed plugin and affinity work stays planned until a faithful lane and provenance exist.</a:t>
+              <a:t> — Common evaluator policy, hosted fixtures, dashboards, artifact retention, and runner contracts.</a:t>
             </a:r>
           </a:p>
         </p:txBody>
@@ -30345,243 +30239,6 @@
           <a:lstStyle xmlns:a="http://schemas.openxmlformats.org/drawingml/2006/main"/>
           <a:p xmlns:a="http://schemas.openxmlformats.org/drawingml/2006/main">
             <a:r>
-              <a:t>What project ownership would look like</a:t>
-            </a:r>
-          </a:p>
-        </p:txBody>
-      </p:sp>
-      <p:sp>
-        <p:nvSpPr>
-          <p:cNvPr id="3" name="Content Placeholder 2">
-            <a:extLst xmlns:a="http://schemas.openxmlformats.org/drawingml/2006/main">
-              <a:ext uri="{FF2B5EF4-FFF2-40B4-BE49-F238E27FC236}">
-                <a16:creationId xmlns:a16="http://schemas.microsoft.com/office/drawing/2014/main" id="{ECF5C9F1-2691-0BC9-F1E1-01CECB857FE3}"/>
-              </a:ext>
-            </a:extLst>
-          </p:cNvPr>
-          <p:cNvSpPr>
-            <a:spLocks xmlns:a="http://schemas.openxmlformats.org/drawingml/2006/main" noGrp="1"/>
-          </p:cNvSpPr>
-          <p:nvPr>
-            <p:ph type="body" idx="1"/>
-          </p:nvPr>
-        </p:nvSpPr>
-        <p:spPr>
-          <a:xfrm xmlns:a="http://schemas.openxmlformats.org/drawingml/2006/main">
-            <a:off x="838200" y="1825625"/>
-            <a:ext cx="10515600" cy="4351200"/>
-          </a:xfrm>
-        </p:spPr>
-        <p:txBody>
-          <a:bodyPr xmlns:a="http://schemas.openxmlformats.org/drawingml/2006/main" wrap="square" anchor="t">
-            <a:normAutofit fontScale="100000"/>
-          </a:bodyPr>
-          <a:lstStyle xmlns:a="http://schemas.openxmlformats.org/drawingml/2006/main"/>
-          <a:p xmlns:a="http://schemas.openxmlformats.org/drawingml/2006/main">
-            <a:pPr marL="30" indent="-18">
-              <a:spcAft>
-                <a:spcPts val="10"/>
-              </a:spcAft>
-              <a:buChar char="•"/>
-              <a:defRPr sz="1913">
-                <a:solidFill>
-                  <a:srgbClr val="000000"/>
-                </a:solidFill>
-              </a:defRPr>
-            </a:pPr>
-            <a:r>
-              <a:rPr sz="1913" b="1">
-                <a:solidFill>
-                  <a:srgbClr val="000000"/>
-                </a:solidFill>
-              </a:rPr>
-              <a:t> Review launch and API guidance</a:t>
-            </a:r>
-            <a:r>
-              <a:rPr sz="1913">
-                <a:solidFill>
-                  <a:srgbClr val="000000"/>
-                </a:solidFill>
-              </a:rPr>
-              <a:t> — Especially current C API status, GPU/plugin behavior, framework integration, and environment conventions.</a:t>
-            </a:r>
-          </a:p>
-          <a:p xmlns:a="http://schemas.openxmlformats.org/drawingml/2006/main">
-            <a:pPr marL="30" indent="-18">
-              <a:spcAft>
-                <a:spcPts val="10"/>
-              </a:spcAft>
-              <a:buChar char="•"/>
-              <a:defRPr sz="1913">
-                <a:solidFill>
-                  <a:srgbClr val="000000"/>
-                </a:solidFill>
-              </a:defRPr>
-            </a:pPr>
-            <a:r>
-              <a:rPr sz="1913" b="1">
-                <a:solidFill>
-                  <a:srgbClr val="000000"/>
-                </a:solidFill>
-              </a:rPr>
-              <a:t> Validate hang-triage order</a:t>
-            </a:r>
-            <a:r>
-              <a:rPr sz="1913">
-                <a:solidFill>
-                  <a:srgbClr val="000000"/>
-                </a:solidFill>
-              </a:rPr>
-              <a:t> — Ensure the evidence sequence matches how maintainers actually debug incidents.</a:t>
-            </a:r>
-          </a:p>
-          <a:p xmlns:a="http://schemas.openxmlformats.org/drawingml/2006/main">
-            <a:pPr marL="30" indent="-18">
-              <a:spcAft>
-                <a:spcPts val="10"/>
-              </a:spcAft>
-              <a:buChar char="•"/>
-              <a:defRPr sz="1913">
-                <a:solidFill>
-                  <a:srgbClr val="000000"/>
-                </a:solidFill>
-              </a:defRPr>
-            </a:pPr>
-            <a:r>
-              <a:rPr sz="1913" b="1">
-                <a:solidFill>
-                  <a:srgbClr val="000000"/>
-                </a:solidFill>
-              </a:rPr>
-              <a:t> Supply authentic distributed cases</a:t>
-            </a:r>
-            <a:r>
-              <a:rPr sz="1913">
-                <a:solidFill>
-                  <a:srgbClr val="000000"/>
-                </a:solidFill>
-              </a:rPr>
-              <a:t> — The highest-value next step is a reproducible plugin or rank-visibility incident.</a:t>
-            </a:r>
-          </a:p>
-          <a:p xmlns:a="http://schemas.openxmlformats.org/drawingml/2006/main">
-            <a:pPr marL="30" indent="-18">
-              <a:spcAft>
-                <a:spcPts val="10"/>
-              </a:spcAft>
-              <a:buChar char="•"/>
-              <a:defRPr sz="1913">
-                <a:solidFill>
-                  <a:srgbClr val="000000"/>
-                </a:solidFill>
-              </a:defRPr>
-            </a:pPr>
-            <a:r>
-              <a:rPr sz="1913" b="1">
-                <a:solidFill>
-                  <a:srgbClr val="000000"/>
-                </a:solidFill>
-              </a:rPr>
-              <a:t> UXL keeps the machinery</a:t>
-            </a:r>
-            <a:r>
-              <a:rPr sz="1913">
-                <a:solidFill>
-                  <a:srgbClr val="000000"/>
-                </a:solidFill>
-              </a:rPr>
-              <a:t> — Common evaluator policy, hosted fixtures, dashboards, artifact retention, and runner contracts.</a:t>
-            </a:r>
-          </a:p>
-        </p:txBody>
-      </p:sp>
-      <p:sp>
-        <p:nvSpPr>
-          <p:cNvPr id="7" name="TextBox 6">
-            <a:extLst xmlns:a="http://schemas.openxmlformats.org/drawingml/2006/main">
-              <a:ext uri="{FF2B5EF4-FFF2-40B4-BE49-F238E27FC236}">
-                <a16:creationId xmlns:a16="http://schemas.microsoft.com/office/drawing/2014/main" id="{E2E6F043-0F84-54F7-A567-6E5851801779}"/>
-              </a:ext>
-            </a:extLst>
-          </p:cNvPr>
-          <p:cNvSpPr>
-            <a:spLocks xmlns:a="http://schemas.openxmlformats.org/drawingml/2006/main" noGrp="1"/>
-          </p:cNvSpPr>
-          <p:nvPr/>
-        </p:nvSpPr>
-        <p:spPr>
-          <a:xfrm xmlns:a="http://schemas.openxmlformats.org/drawingml/2006/main">
-            <a:off x="696174" y="6338986"/>
-            <a:ext cx="284052" cy="307777"/>
-          </a:xfrm>
-          <a:prstGeom xmlns:a="http://schemas.openxmlformats.org/drawingml/2006/main" prst="rect">
-            <a:avLst/>
-          </a:prstGeom>
-          <a:noFill xmlns:a="http://schemas.openxmlformats.org/drawingml/2006/main"/>
-        </p:spPr>
-        <p:txBody>
-          <a:bodyPr xmlns:a="http://schemas.openxmlformats.org/drawingml/2006/main" wrap="none">
-            <a:spAutoFit/>
-          </a:bodyPr>
-          <a:lstStyle xmlns:a="http://schemas.openxmlformats.org/drawingml/2006/main"/>
-          <a:p xmlns:a="http://schemas.openxmlformats.org/drawingml/2006/main">
-            <a:r>
-              <a:t>6</a:t>
-            </a:r>
-          </a:p>
-        </p:txBody>
-      </p:sp>
-    </p:spTree>
-    <p:extLst>
-      <p:ext uri="{BB962C8B-B14F-4D97-AF65-F5344CB8AC3E}">
-        <p14:creationId xmlns:p14="http://schemas.microsoft.com/office/powerpoint/2010/main" val="1742728663"/>
-      </p:ext>
-    </p:extLst>
-  </p:cSld>
-</p:sld>
-</file>
-
-<file path=ppt/slides/slide7.xml><?xml version="1.0" encoding="utf-8"?>
-<p:sld xmlns:p="http://schemas.openxmlformats.org/presentationml/2006/main">
-  <p:cSld>
-    <p:spTree>
-      <p:nvGrpSpPr>
-        <p:cNvPr id="1" name=""/>
-        <p:cNvGrpSpPr/>
-        <p:nvPr/>
-      </p:nvGrpSpPr>
-      <p:grpSpPr>
-        <a:xfrm xmlns:a="http://schemas.openxmlformats.org/drawingml/2006/main"/>
-      </p:grpSpPr>
-      <p:sp>
-        <p:nvSpPr>
-          <p:cNvPr id="2" name="Title 1">
-            <a:extLst xmlns:a="http://schemas.openxmlformats.org/drawingml/2006/main">
-              <a:ext uri="{FF2B5EF4-FFF2-40B4-BE49-F238E27FC236}">
-                <a16:creationId xmlns:a16="http://schemas.microsoft.com/office/drawing/2014/main" id="{F64C2A24-546D-C55C-2C52-97A4957F67E0}"/>
-              </a:ext>
-            </a:extLst>
-          </p:cNvPr>
-          <p:cNvSpPr>
-            <a:spLocks xmlns:a="http://schemas.openxmlformats.org/drawingml/2006/main" noGrp="1"/>
-          </p:cNvSpPr>
-          <p:nvPr>
-            <p:ph type="title" idx="0"/>
-          </p:nvPr>
-        </p:nvSpPr>
-        <p:spPr>
-          <a:xfrm xmlns:a="http://schemas.openxmlformats.org/drawingml/2006/main">
-            <a:off x="838200" y="365125"/>
-            <a:ext cx="10515600" cy="1325700"/>
-          </a:xfrm>
-        </p:spPr>
-        <p:txBody>
-          <a:bodyPr xmlns:a="http://schemas.openxmlformats.org/drawingml/2006/main">
-            <a:normAutofit fontScale="100000"/>
-          </a:bodyPr>
-          <a:lstStyle xmlns:a="http://schemas.openxmlformats.org/drawingml/2006/main"/>
-          <a:p xmlns:a="http://schemas.openxmlformats.org/drawingml/2006/main">
-            <a:r>
               <a:t>A focused 30-minute maintainer review</a:t>
             </a:r>
           </a:p>
@@ -30792,7 +30449,7 @@
           <a:lstStyle xmlns:a="http://schemas.openxmlformats.org/drawingml/2006/main"/>
           <a:p xmlns:a="http://schemas.openxmlformats.org/drawingml/2006/main">
             <a:r>
-              <a:t>7</a:t>
+              <a:t>6</a:t>
             </a:r>
           </a:p>
         </p:txBody>

</xml_diff>

<commit_message>
Simplify maintainer briefing decks (#19)
</commit_message>
<xml_diff>
--- a/evaluation/dashboard/public/decks/uxl-oneccl-maintainer-briefing.pptx
+++ b/evaluation/dashboard/public/decks/uxl-oneccl-maintainer-briefing.pptx
@@ -2,20 +2,19 @@
 <file path=ppt/presentation.xml><?xml version="1.0" encoding="utf-8"?>
 <p:presentation xmlns:p="http://schemas.openxmlformats.org/presentationml/2006/main">
   <p:sldMasterIdLst>
-    <p:sldMasterId xmlns:r="http://schemas.openxmlformats.org/officeDocument/2006/relationships" id="2147483648" r:id="R2adc7912e30b41f2"/>
-    <p:sldMasterId xmlns:r="http://schemas.openxmlformats.org/officeDocument/2006/relationships" id="2147483665" r:id="R6a3ba7107e0b4410"/>
+    <p:sldMasterId xmlns:r="http://schemas.openxmlformats.org/officeDocument/2006/relationships" id="2147483648" r:id="Re0e0fd93dc0f4a1b"/>
+    <p:sldMasterId xmlns:r="http://schemas.openxmlformats.org/officeDocument/2006/relationships" id="2147483665" r:id="Rf01571311831434a"/>
   </p:sldMasterIdLst>
   <p:notesMasterIdLst>
-    <p:notesMasterId xmlns:r="http://schemas.openxmlformats.org/officeDocument/2006/relationships" r:id="R0b3d67f7f83a4d10"/>
+    <p:notesMasterId xmlns:r="http://schemas.openxmlformats.org/officeDocument/2006/relationships" r:id="R57bb29e9678c4f5c"/>
   </p:notesMasterIdLst>
   <p:sldIdLst>
-    <p:sldId xmlns:r="http://schemas.openxmlformats.org/officeDocument/2006/relationships" id="256" r:id="Ra5e97bf2674949f9"/>
-    <p:sldId xmlns:r="http://schemas.openxmlformats.org/officeDocument/2006/relationships" id="257" r:id="Rd090db69b4c54099"/>
-    <p:sldId xmlns:r="http://schemas.openxmlformats.org/officeDocument/2006/relationships" id="258" r:id="R1f076a1b0278482f"/>
-    <p:sldId xmlns:r="http://schemas.openxmlformats.org/officeDocument/2006/relationships" id="259" r:id="Rc5519593742a4072"/>
-    <p:sldId xmlns:r="http://schemas.openxmlformats.org/officeDocument/2006/relationships" id="260" r:id="Rfc4d6ddb1bd746c6"/>
-    <p:sldId xmlns:r="http://schemas.openxmlformats.org/officeDocument/2006/relationships" id="261" r:id="R66cae8eba7c74cb0"/>
-    <p:sldId xmlns:r="http://schemas.openxmlformats.org/officeDocument/2006/relationships" id="262" r:id="R300e94bb1b8144c2"/>
+    <p:sldId xmlns:r="http://schemas.openxmlformats.org/officeDocument/2006/relationships" id="256" r:id="R38123e27fbeb4381"/>
+    <p:sldId xmlns:r="http://schemas.openxmlformats.org/officeDocument/2006/relationships" id="257" r:id="R3d30f4742126454d"/>
+    <p:sldId xmlns:r="http://schemas.openxmlformats.org/officeDocument/2006/relationships" id="258" r:id="Rabe0f841331d4f03"/>
+    <p:sldId xmlns:r="http://schemas.openxmlformats.org/officeDocument/2006/relationships" id="259" r:id="Rb74f31b3cbd142b8"/>
+    <p:sldId xmlns:r="http://schemas.openxmlformats.org/officeDocument/2006/relationships" id="260" r:id="Ref29dc64ad704671"/>
+    <p:sldId xmlns:r="http://schemas.openxmlformats.org/officeDocument/2006/relationships" id="261" r:id="Rdfafb0dda9854911"/>
   </p:sldIdLst>
   <p:sldSz cx="12192000" cy="6858000"/>
   <p:notesSz cx="6858000" cy="9144000"/>
@@ -619,7 +618,7 @@
           </a:p>
           <a:p xmlns:a="http://schemas.openxmlformats.org/drawingml/2006/main">
             <a:r>
-              <a:t>Speaker cue: Why this is useful to oneCCL at first glance</a:t>
+              <a:t>Speaker cue: What the skill tells an agent today</a:t>
             </a:r>
           </a:p>
         </p:txBody>
@@ -724,7 +723,7 @@
           </a:p>
           <a:p xmlns:a="http://schemas.openxmlformats.org/drawingml/2006/main">
             <a:r>
-              <a:t>Speaker cue: What the skill tells an agent today</a:t>
+              <a:t>Speaker cue: Evaluation inventory: 5 implemented, 2 distributed gaps</a:t>
             </a:r>
           </a:p>
         </p:txBody>
@@ -829,7 +828,7 @@
           </a:p>
           <a:p xmlns:a="http://schemas.openxmlformats.org/drawingml/2006/main">
             <a:r>
-              <a:t>Speaker cue: Evaluation inventory: 5 implemented, 2 distributed gaps</a:t>
+              <a:t>Speaker cue: How we chose the content</a:t>
             </a:r>
           </a:p>
         </p:txBody>
@@ -934,7 +933,7 @@
           </a:p>
           <a:p xmlns:a="http://schemas.openxmlformats.org/drawingml/2006/main">
             <a:r>
-              <a:t>Speaker cue: How we chose the content</a:t>
+              <a:t>Speaker cue: What project ownership would look like</a:t>
             </a:r>
           </a:p>
         </p:txBody>
@@ -965,111 +964,6 @@
 </file>
 
 <file path=ppt/notesSlides/notesSlide6.xml><?xml version="1.0" encoding="utf-8"?>
-<p:notes xmlns:p="http://schemas.openxmlformats.org/presentationml/2006/main">
-  <p:cSld>
-    <p:spTree>
-      <p:nvGrpSpPr>
-        <p:cNvPr id="1" name=""/>
-        <p:cNvGrpSpPr/>
-        <p:nvPr/>
-      </p:nvGrpSpPr>
-      <p:grpSpPr>
-        <a:xfrm xmlns:a="http://schemas.openxmlformats.org/drawingml/2006/main"/>
-      </p:grpSpPr>
-      <p:sp>
-        <p:nvSpPr>
-          <p:cNvPr id="2" name="Slide Image Placeholder 1"/>
-          <p:cNvSpPr>
-            <a:spLocks xmlns:a="http://schemas.openxmlformats.org/drawingml/2006/main" noGrp="1"/>
-          </p:cNvSpPr>
-          <p:nvPr>
-            <p:ph type="sldImg" idx="0"/>
-          </p:nvPr>
-        </p:nvSpPr>
-        <p:spPr/>
-      </p:sp>
-      <p:sp>
-        <p:nvSpPr>
-          <p:cNvPr id="3" name="Notes Placeholder 2"/>
-          <p:cNvSpPr>
-            <a:spLocks xmlns:a="http://schemas.openxmlformats.org/drawingml/2006/main" noGrp="1"/>
-          </p:cNvSpPr>
-          <p:nvPr>
-            <p:ph type="body" idx="1"/>
-          </p:nvPr>
-        </p:nvSpPr>
-        <p:spPr/>
-        <p:txBody>
-          <a:bodyPr xmlns:a="http://schemas.openxmlformats.org/drawingml/2006/main"/>
-          <a:lstStyle xmlns:a="http://schemas.openxmlformats.org/drawingml/2006/main"/>
-          <a:p xmlns:a="http://schemas.openxmlformats.org/drawingml/2006/main">
-            <a:r>
-              <a:t>[Sources]</a:t>
-            </a:r>
-          </a:p>
-          <a:p xmlns:a="http://schemas.openxmlformats.org/drawingml/2006/main">
-            <a:r>
-              <a:t>- https://github.com/uxlfoundation/skills/tree/main/skills/uxl-oneccl</a:t>
-            </a:r>
-          </a:p>
-          <a:p xmlns:a="http://schemas.openxmlformats.org/drawingml/2006/main">
-            <a:r>
-              <a:t>- https://github.com/uxlfoundation/skills/blob/main/skill-cards/uxl-oneccl.md</a:t>
-            </a:r>
-          </a:p>
-          <a:p xmlns:a="http://schemas.openxmlformats.org/drawingml/2006/main">
-            <a:r>
-              <a:t>- https://github.com/uxlfoundation/skills/blob/main/evaluation/harbor/results/2026-08-27-oneccl-zero-count-fixture.md</a:t>
-            </a:r>
-          </a:p>
-          <a:p xmlns:a="http://schemas.openxmlformats.org/drawingml/2006/main">
-            <a:r>
-              <a:t>- https://github.com/uxlfoundation/skills/blob/main/evaluation/harbor/suites.json</a:t>
-            </a:r>
-          </a:p>
-          <a:p xmlns:a="http://schemas.openxmlformats.org/drawingml/2006/main">
-            <a:r>
-              <a:t>[/Sources]</a:t>
-            </a:r>
-          </a:p>
-          <a:p xmlns:a="http://schemas.openxmlformats.org/drawingml/2006/main">
-            <a:r>
-              <a:t/>
-            </a:r>
-          </a:p>
-          <a:p xmlns:a="http://schemas.openxmlformats.org/drawingml/2006/main">
-            <a:r>
-              <a:t>Speaker cue: What project ownership would look like</a:t>
-            </a:r>
-          </a:p>
-        </p:txBody>
-      </p:sp>
-      <p:sp>
-        <p:nvSpPr>
-          <p:cNvPr id="4" name="Slide Number Placeholder 3"/>
-          <p:cNvSpPr>
-            <a:spLocks xmlns:a="http://schemas.openxmlformats.org/drawingml/2006/main" noGrp="1"/>
-          </p:cNvSpPr>
-          <p:nvPr>
-            <p:ph type="sldNum" idx="5"/>
-          </p:nvPr>
-        </p:nvSpPr>
-        <p:spPr/>
-        <p:txBody>
-          <a:bodyPr xmlns:a="http://schemas.openxmlformats.org/drawingml/2006/main"/>
-          <a:lstStyle xmlns:a="http://schemas.openxmlformats.org/drawingml/2006/main"/>
-          <a:p xmlns:a="http://schemas.openxmlformats.org/drawingml/2006/main"/>
-        </p:txBody>
-      </p:sp>
-    </p:spTree>
-  </p:cSld>
-  <p:clrMapOvr>
-    <a:masterClrMapping xmlns:a="http://schemas.openxmlformats.org/drawingml/2006/main"/>
-  </p:clrMapOvr>
-</p:notes>
-</file>
-
-<file path=ppt/notesSlides/notesSlide7.xml><?xml version="1.0" encoding="utf-8"?>
 <p:notes xmlns:p="http://schemas.openxmlformats.org/presentationml/2006/main">
   <p:cSld>
     <p:spTree>
@@ -1180,7 +1074,7 @@
     <p:bg>
       <p:bgPr>
         <a:blipFill xmlns:a="http://schemas.openxmlformats.org/drawingml/2006/main">
-          <a:blip xmlns:r="http://schemas.openxmlformats.org/officeDocument/2006/relationships" r:embed="R1ed66fd0a69847be">
+          <a:blip xmlns:r="http://schemas.openxmlformats.org/officeDocument/2006/relationships" r:embed="R0fa7fd516c284d0a">
             <a:alphaModFix/>
           </a:blip>
           <a:stretch>
@@ -1615,7 +1509,7 @@
           <p:nvPr/>
         </p:nvPicPr>
         <p:blipFill rotWithShape="1">
-          <a:blip xmlns:r="http://schemas.openxmlformats.org/officeDocument/2006/relationships" xmlns:a="http://schemas.openxmlformats.org/drawingml/2006/main" r:embed="R0a6be1f029654419">
+          <a:blip xmlns:r="http://schemas.openxmlformats.org/officeDocument/2006/relationships" xmlns:a="http://schemas.openxmlformats.org/drawingml/2006/main" r:embed="R5c1903a0958a4b4e">
             <a:alphaModFix/>
           </a:blip>
           <a:srcRect xmlns:a="http://schemas.openxmlformats.org/drawingml/2006/main" l="0" t="0" r="0" b="0"/>
@@ -1645,7 +1539,7 @@
     <p:bg>
       <p:bgPr>
         <a:blipFill xmlns:a="http://schemas.openxmlformats.org/drawingml/2006/main">
-          <a:blip xmlns:r="http://schemas.openxmlformats.org/officeDocument/2006/relationships" r:embed="R35e8aebf0b104db9">
+          <a:blip xmlns:r="http://schemas.openxmlformats.org/officeDocument/2006/relationships" r:embed="R18e4cb7744ac4f30">
             <a:alphaModFix/>
           </a:blip>
           <a:stretch>
@@ -2679,7 +2573,7 @@
           <p:nvPr/>
         </p:nvPicPr>
         <p:blipFill rotWithShape="1">
-          <a:blip xmlns:r="http://schemas.openxmlformats.org/officeDocument/2006/relationships" xmlns:a="http://schemas.openxmlformats.org/drawingml/2006/main" r:embed="R0d11dd3c264d4a3e">
+          <a:blip xmlns:r="http://schemas.openxmlformats.org/officeDocument/2006/relationships" xmlns:a="http://schemas.openxmlformats.org/drawingml/2006/main" r:embed="R49274d62641c4f06">
             <a:alphaModFix/>
           </a:blip>
           <a:srcRect xmlns:a="http://schemas.openxmlformats.org/drawingml/2006/main" l="0" t="0" r="0" b="0"/>
@@ -3703,7 +3597,7 @@
           <p:nvPr/>
         </p:nvPicPr>
         <p:blipFill rotWithShape="1">
-          <a:blip xmlns:r="http://schemas.openxmlformats.org/officeDocument/2006/relationships" xmlns:a="http://schemas.openxmlformats.org/drawingml/2006/main" r:embed="R8a720f66025b4c15">
+          <a:blip xmlns:r="http://schemas.openxmlformats.org/officeDocument/2006/relationships" xmlns:a="http://schemas.openxmlformats.org/drawingml/2006/main" r:embed="Rb06982f7fb454e72">
             <a:alphaModFix/>
           </a:blip>
           <a:srcRect xmlns:a="http://schemas.openxmlformats.org/drawingml/2006/main" l="0" t="0" r="0" b="0"/>
@@ -3733,7 +3627,7 @@
     <p:bg>
       <p:bgPr>
         <a:blipFill xmlns:a="http://schemas.openxmlformats.org/drawingml/2006/main">
-          <a:blip xmlns:r="http://schemas.openxmlformats.org/officeDocument/2006/relationships" r:embed="Rd0855cef7158487f">
+          <a:blip xmlns:r="http://schemas.openxmlformats.org/officeDocument/2006/relationships" r:embed="R226dd13fd4024685">
             <a:alphaModFix/>
           </a:blip>
           <a:stretch>
@@ -5007,7 +4901,7 @@
           <p:nvPr/>
         </p:nvPicPr>
         <p:blipFill rotWithShape="1">
-          <a:blip xmlns:r="http://schemas.openxmlformats.org/officeDocument/2006/relationships" xmlns:a="http://schemas.openxmlformats.org/drawingml/2006/main" r:embed="R0e93b3764f7c4cad">
+          <a:blip xmlns:r="http://schemas.openxmlformats.org/officeDocument/2006/relationships" xmlns:a="http://schemas.openxmlformats.org/drawingml/2006/main" r:embed="R4ff978f10eca4088">
             <a:alphaModFix/>
           </a:blip>
           <a:srcRect xmlns:a="http://schemas.openxmlformats.org/drawingml/2006/main" l="0" t="0" r="0" b="0"/>
@@ -8251,7 +8145,7 @@
           <p:nvPr/>
         </p:nvPicPr>
         <p:blipFill rotWithShape="1">
-          <a:blip xmlns:r="http://schemas.openxmlformats.org/officeDocument/2006/relationships" xmlns:a="http://schemas.openxmlformats.org/drawingml/2006/main" r:embed="Re7d41a51a3964723">
+          <a:blip xmlns:r="http://schemas.openxmlformats.org/officeDocument/2006/relationships" xmlns:a="http://schemas.openxmlformats.org/drawingml/2006/main" r:embed="R1236982942504250">
             <a:alphaModFix/>
           </a:blip>
           <a:srcRect xmlns:a="http://schemas.openxmlformats.org/drawingml/2006/main" l="0" t="0" r="0" b="0"/>
@@ -9989,7 +9883,7 @@
           <p:nvPr/>
         </p:nvPicPr>
         <p:blipFill rotWithShape="1">
-          <a:blip xmlns:r="http://schemas.openxmlformats.org/officeDocument/2006/relationships" xmlns:a="http://schemas.openxmlformats.org/drawingml/2006/main" r:embed="R0e9c0a1b65504a25">
+          <a:blip xmlns:r="http://schemas.openxmlformats.org/officeDocument/2006/relationships" xmlns:a="http://schemas.openxmlformats.org/drawingml/2006/main" r:embed="Rff5b327dc46c43b3">
             <a:alphaModFix/>
           </a:blip>
           <a:srcRect xmlns:a="http://schemas.openxmlformats.org/drawingml/2006/main" l="0" t="0" r="0" b="0"/>
@@ -16818,7 +16712,7 @@
     <p:bg>
       <p:bgPr>
         <a:blipFill xmlns:a="http://schemas.openxmlformats.org/drawingml/2006/main">
-          <a:blip xmlns:r="http://schemas.openxmlformats.org/officeDocument/2006/relationships" r:embed="Ra2ddb1c370bb4f2b">
+          <a:blip xmlns:r="http://schemas.openxmlformats.org/officeDocument/2006/relationships" r:embed="R1780b706b99f4fe5">
             <a:alphaModFix/>
           </a:blip>
           <a:stretch>
@@ -17253,7 +17147,7 @@
           <p:nvPr/>
         </p:nvPicPr>
         <p:blipFill rotWithShape="1">
-          <a:blip xmlns:r="http://schemas.openxmlformats.org/officeDocument/2006/relationships" xmlns:a="http://schemas.openxmlformats.org/drawingml/2006/main" r:embed="R4212a50cadfa4c26">
+          <a:blip xmlns:r="http://schemas.openxmlformats.org/officeDocument/2006/relationships" xmlns:a="http://schemas.openxmlformats.org/drawingml/2006/main" r:embed="Rdd37442a9e8940a6">
             <a:alphaModFix/>
           </a:blip>
           <a:srcRect xmlns:a="http://schemas.openxmlformats.org/drawingml/2006/main" l="0" t="0" r="0" b="0"/>
@@ -17283,7 +17177,7 @@
     <p:bg>
       <p:bgPr>
         <a:blipFill xmlns:a="http://schemas.openxmlformats.org/drawingml/2006/main">
-          <a:blip xmlns:r="http://schemas.openxmlformats.org/officeDocument/2006/relationships" r:embed="R4eae026f2a304686">
+          <a:blip xmlns:r="http://schemas.openxmlformats.org/officeDocument/2006/relationships" r:embed="R2f4e6ebb8454423a">
             <a:alphaModFix/>
           </a:blip>
           <a:stretch>
@@ -17916,7 +17810,7 @@
           <p:nvPr/>
         </p:nvPicPr>
         <p:blipFill rotWithShape="1">
-          <a:blip xmlns:r="http://schemas.openxmlformats.org/officeDocument/2006/relationships" xmlns:a="http://schemas.openxmlformats.org/drawingml/2006/main" r:embed="R57cc49e7e2314785">
+          <a:blip xmlns:r="http://schemas.openxmlformats.org/officeDocument/2006/relationships" xmlns:a="http://schemas.openxmlformats.org/drawingml/2006/main" r:embed="R85e6aa761cb34980">
             <a:alphaModFix/>
           </a:blip>
           <a:srcRect xmlns:a="http://schemas.openxmlformats.org/drawingml/2006/main" l="0" t="0" r="0" b="0"/>
@@ -18376,7 +18270,7 @@
     <p:bg>
       <p:bgPr>
         <a:blipFill xmlns:a="http://schemas.openxmlformats.org/drawingml/2006/main">
-          <a:blip xmlns:r="http://schemas.openxmlformats.org/officeDocument/2006/relationships" r:embed="R2ae732db6c9e450f">
+          <a:blip xmlns:r="http://schemas.openxmlformats.org/officeDocument/2006/relationships" r:embed="Ree0cb5b201094d84">
             <a:alphaModFix/>
           </a:blip>
           <a:stretch>
@@ -19009,7 +18903,7 @@
           <p:nvPr/>
         </p:nvPicPr>
         <p:blipFill rotWithShape="1">
-          <a:blip xmlns:r="http://schemas.openxmlformats.org/officeDocument/2006/relationships" xmlns:a="http://schemas.openxmlformats.org/drawingml/2006/main" r:embed="Rd4ec2480967b4fff">
+          <a:blip xmlns:r="http://schemas.openxmlformats.org/officeDocument/2006/relationships" xmlns:a="http://schemas.openxmlformats.org/drawingml/2006/main" r:embed="Rf70c23b3cd3d4052">
             <a:alphaModFix/>
           </a:blip>
           <a:srcRect xmlns:a="http://schemas.openxmlformats.org/drawingml/2006/main" l="0" t="0" r="0" b="0"/>
@@ -21665,7 +21559,7 @@
           <p:nvPr/>
         </p:nvPicPr>
         <p:blipFill rotWithShape="1">
-          <a:blip xmlns:r="http://schemas.openxmlformats.org/officeDocument/2006/relationships" xmlns:a="http://schemas.openxmlformats.org/drawingml/2006/main" r:embed="Rf55012417bb64b6d">
+          <a:blip xmlns:r="http://schemas.openxmlformats.org/officeDocument/2006/relationships" xmlns:a="http://schemas.openxmlformats.org/drawingml/2006/main" r:embed="R28070925d1074bb4">
             <a:alphaModFix/>
           </a:blip>
           <a:srcRect xmlns:a="http://schemas.openxmlformats.org/drawingml/2006/main" l="0" t="0" r="0" b="0"/>
@@ -21695,7 +21589,7 @@
     <p:bg>
       <p:bgPr>
         <a:blipFill xmlns:a="http://schemas.openxmlformats.org/drawingml/2006/main">
-          <a:blip xmlns:r="http://schemas.openxmlformats.org/officeDocument/2006/relationships" r:embed="Rdb645905176643a3">
+          <a:blip xmlns:r="http://schemas.openxmlformats.org/officeDocument/2006/relationships" r:embed="R9e0e8be0ee984e55">
             <a:alphaModFix/>
           </a:blip>
           <a:stretch>
@@ -22539,7 +22433,7 @@
           <p:nvPr/>
         </p:nvPicPr>
         <p:blipFill rotWithShape="1">
-          <a:blip xmlns:r="http://schemas.openxmlformats.org/officeDocument/2006/relationships" xmlns:a="http://schemas.openxmlformats.org/drawingml/2006/main" r:embed="Rd540fa12077944d9">
+          <a:blip xmlns:r="http://schemas.openxmlformats.org/officeDocument/2006/relationships" xmlns:a="http://schemas.openxmlformats.org/drawingml/2006/main" r:embed="R658cc3de10f24f1d">
             <a:alphaModFix/>
           </a:blip>
           <a:srcRect xmlns:a="http://schemas.openxmlformats.org/drawingml/2006/main" l="0" t="0" r="0" b="0"/>
@@ -22569,7 +22463,7 @@
     <p:bg>
       <p:bgPr>
         <a:blipFill xmlns:a="http://schemas.openxmlformats.org/drawingml/2006/main">
-          <a:blip xmlns:r="http://schemas.openxmlformats.org/officeDocument/2006/relationships" r:embed="Rf8b43fe2c9134d6e">
+          <a:blip xmlns:r="http://schemas.openxmlformats.org/officeDocument/2006/relationships" r:embed="R7e87af6f4871491c">
             <a:alphaModFix/>
           </a:blip>
           <a:stretch>
@@ -23517,7 +23411,7 @@
           <p:nvPr/>
         </p:nvPicPr>
         <p:blipFill rotWithShape="1">
-          <a:blip xmlns:r="http://schemas.openxmlformats.org/officeDocument/2006/relationships" xmlns:a="http://schemas.openxmlformats.org/drawingml/2006/main" r:embed="Rb4a68ce645964524">
+          <a:blip xmlns:r="http://schemas.openxmlformats.org/officeDocument/2006/relationships" xmlns:a="http://schemas.openxmlformats.org/drawingml/2006/main" r:embed="R53de99c2ca2c4b97">
             <a:alphaModFix/>
           </a:blip>
           <a:srcRect xmlns:a="http://schemas.openxmlformats.org/drawingml/2006/main" l="0" t="0" r="0" b="0"/>
@@ -23547,7 +23441,7 @@
     <p:bg>
       <p:bgPr>
         <a:blipFill xmlns:a="http://schemas.openxmlformats.org/drawingml/2006/main">
-          <a:blip xmlns:r="http://schemas.openxmlformats.org/officeDocument/2006/relationships" r:embed="Ra5e15cb289e54e68">
+          <a:blip xmlns:r="http://schemas.openxmlformats.org/officeDocument/2006/relationships" r:embed="R0c934d4d3daa4765">
             <a:alphaModFix/>
           </a:blip>
           <a:stretch>
@@ -24008,7 +23902,7 @@
           <p:nvPr/>
         </p:nvPicPr>
         <p:blipFill rotWithShape="1">
-          <a:blip xmlns:r="http://schemas.openxmlformats.org/officeDocument/2006/relationships" xmlns:a="http://schemas.openxmlformats.org/drawingml/2006/main" r:embed="Rf5c0d477b2cf4609">
+          <a:blip xmlns:r="http://schemas.openxmlformats.org/officeDocument/2006/relationships" xmlns:a="http://schemas.openxmlformats.org/drawingml/2006/main" r:embed="Rbe4960775d5243ae">
             <a:alphaModFix/>
           </a:blip>
           <a:srcRect xmlns:a="http://schemas.openxmlformats.org/drawingml/2006/main" l="0" t="0" r="0" b="0"/>
@@ -25720,22 +25614,22 @@
   </p:cSld>
   <p:clrMap bg1="lt1" tx1="dk1" bg2="dk2" tx2="lt2" accent1="accent1" accent2="accent2" accent3="accent3" accent4="accent4" accent5="accent5" accent6="accent6" hlink="hlink" folHlink="folHlink"/>
   <p:sldLayoutIdLst>
-    <p:sldLayoutId xmlns:r="http://schemas.openxmlformats.org/officeDocument/2006/relationships" id="2147483649" r:id="R97621fdecee04ae0"/>
-    <p:sldLayoutId xmlns:r="http://schemas.openxmlformats.org/officeDocument/2006/relationships" id="2147483650" r:id="R114f20e322384388"/>
-    <p:sldLayoutId xmlns:r="http://schemas.openxmlformats.org/officeDocument/2006/relationships" id="2147483651" r:id="Rfc13bfd126a9484f"/>
-    <p:sldLayoutId xmlns:r="http://schemas.openxmlformats.org/officeDocument/2006/relationships" id="2147483652" r:id="R0d7ba0b0de1041d8"/>
-    <p:sldLayoutId xmlns:r="http://schemas.openxmlformats.org/officeDocument/2006/relationships" id="2147483653" r:id="R1be8d60a68f2414d"/>
-    <p:sldLayoutId xmlns:r="http://schemas.openxmlformats.org/officeDocument/2006/relationships" id="2147483654" r:id="R45271084f6db4711"/>
-    <p:sldLayoutId xmlns:r="http://schemas.openxmlformats.org/officeDocument/2006/relationships" id="2147483655" r:id="R174499768e9a4dd6"/>
-    <p:sldLayoutId xmlns:r="http://schemas.openxmlformats.org/officeDocument/2006/relationships" id="2147483656" r:id="Rdc1f05025fd74ce4"/>
-    <p:sldLayoutId xmlns:r="http://schemas.openxmlformats.org/officeDocument/2006/relationships" id="2147483657" r:id="R121156b0ae8e4a71"/>
-    <p:sldLayoutId xmlns:r="http://schemas.openxmlformats.org/officeDocument/2006/relationships" id="2147483658" r:id="Rf08b5320ef2b4287"/>
-    <p:sldLayoutId xmlns:r="http://schemas.openxmlformats.org/officeDocument/2006/relationships" id="2147483659" r:id="R121fc4b47a80419d"/>
-    <p:sldLayoutId xmlns:r="http://schemas.openxmlformats.org/officeDocument/2006/relationships" id="2147483660" r:id="Rf16579a443df4bf7"/>
-    <p:sldLayoutId xmlns:r="http://schemas.openxmlformats.org/officeDocument/2006/relationships" id="2147483661" r:id="Rd860cce5811f444a"/>
-    <p:sldLayoutId xmlns:r="http://schemas.openxmlformats.org/officeDocument/2006/relationships" id="2147483662" r:id="R684c7644e7014d9e"/>
-    <p:sldLayoutId xmlns:r="http://schemas.openxmlformats.org/officeDocument/2006/relationships" id="2147483663" r:id="Rd80c69d94afc4e60"/>
-    <p:sldLayoutId xmlns:r="http://schemas.openxmlformats.org/officeDocument/2006/relationships" id="2147483664" r:id="Ra1fd0a7d875c48d5"/>
+    <p:sldLayoutId xmlns:r="http://schemas.openxmlformats.org/officeDocument/2006/relationships" id="2147483649" r:id="R799ede6a78be464f"/>
+    <p:sldLayoutId xmlns:r="http://schemas.openxmlformats.org/officeDocument/2006/relationships" id="2147483650" r:id="R73d8f3143b344c8b"/>
+    <p:sldLayoutId xmlns:r="http://schemas.openxmlformats.org/officeDocument/2006/relationships" id="2147483651" r:id="R8af6d623281a44bc"/>
+    <p:sldLayoutId xmlns:r="http://schemas.openxmlformats.org/officeDocument/2006/relationships" id="2147483652" r:id="Rd1abece36e67438b"/>
+    <p:sldLayoutId xmlns:r="http://schemas.openxmlformats.org/officeDocument/2006/relationships" id="2147483653" r:id="R12a5d0a2882147df"/>
+    <p:sldLayoutId xmlns:r="http://schemas.openxmlformats.org/officeDocument/2006/relationships" id="2147483654" r:id="R3b23b859f5714009"/>
+    <p:sldLayoutId xmlns:r="http://schemas.openxmlformats.org/officeDocument/2006/relationships" id="2147483655" r:id="Rb348f389456a47a7"/>
+    <p:sldLayoutId xmlns:r="http://schemas.openxmlformats.org/officeDocument/2006/relationships" id="2147483656" r:id="Rf72c8454f50042d7"/>
+    <p:sldLayoutId xmlns:r="http://schemas.openxmlformats.org/officeDocument/2006/relationships" id="2147483657" r:id="Rdb6fd195298f4cfe"/>
+    <p:sldLayoutId xmlns:r="http://schemas.openxmlformats.org/officeDocument/2006/relationships" id="2147483658" r:id="Red9b92bc49e949f7"/>
+    <p:sldLayoutId xmlns:r="http://schemas.openxmlformats.org/officeDocument/2006/relationships" id="2147483659" r:id="Rc13890a80f4a4e9e"/>
+    <p:sldLayoutId xmlns:r="http://schemas.openxmlformats.org/officeDocument/2006/relationships" id="2147483660" r:id="Rb9ace67daa914406"/>
+    <p:sldLayoutId xmlns:r="http://schemas.openxmlformats.org/officeDocument/2006/relationships" id="2147483661" r:id="R393c0f8286b54c3c"/>
+    <p:sldLayoutId xmlns:r="http://schemas.openxmlformats.org/officeDocument/2006/relationships" id="2147483662" r:id="R01a1ba7f9fdb419b"/>
+    <p:sldLayoutId xmlns:r="http://schemas.openxmlformats.org/officeDocument/2006/relationships" id="2147483663" r:id="R722863ce344f410d"/>
+    <p:sldLayoutId xmlns:r="http://schemas.openxmlformats.org/officeDocument/2006/relationships" id="2147483664" r:id="Rc068b8e95221435a"/>
   </p:sldLayoutIdLst>
   <p:hf hdr="0" ftr="0" dt="0"/>
   <p:txStyles>
@@ -27928,7 +27822,7 @@
           <p:nvPr/>
         </p:nvPicPr>
         <p:blipFill rotWithShape="1">
-          <a:blip xmlns:r="http://schemas.openxmlformats.org/officeDocument/2006/relationships" xmlns:a="http://schemas.openxmlformats.org/drawingml/2006/main" r:embed="Rb9047647672d46b2">
+          <a:blip xmlns:r="http://schemas.openxmlformats.org/officeDocument/2006/relationships" xmlns:a="http://schemas.openxmlformats.org/drawingml/2006/main" r:embed="R8fbeb4e15b40427e">
             <a:alphaModFix/>
           </a:blip>
           <a:srcRect xmlns:a="http://schemas.openxmlformats.org/drawingml/2006/main" l="0" t="0" r="0" b="0"/>
@@ -27951,19 +27845,19 @@
   </p:cSld>
   <p:clrMap bg1="lt1" tx1="dk1" bg2="dk2" tx2="lt2" accent1="accent1" accent2="accent2" accent3="accent3" accent4="accent4" accent5="accent5" accent6="accent6" hlink="hlink" folHlink="folHlink"/>
   <p:sldLayoutIdLst>
-    <p:sldLayoutId xmlns:r="http://schemas.openxmlformats.org/officeDocument/2006/relationships" id="2147483666" r:id="Rae0e9029b0fe425e"/>
-    <p:sldLayoutId xmlns:r="http://schemas.openxmlformats.org/officeDocument/2006/relationships" id="2147483667" r:id="R16c9b81c4be944ec"/>
-    <p:sldLayoutId xmlns:r="http://schemas.openxmlformats.org/officeDocument/2006/relationships" id="2147483668" r:id="Re4fd9f31b62a432f"/>
-    <p:sldLayoutId xmlns:r="http://schemas.openxmlformats.org/officeDocument/2006/relationships" id="2147483669" r:id="R5e7cd2e49e3e43fa"/>
-    <p:sldLayoutId xmlns:r="http://schemas.openxmlformats.org/officeDocument/2006/relationships" id="2147483670" r:id="R0b46da66d5d84e40"/>
-    <p:sldLayoutId xmlns:r="http://schemas.openxmlformats.org/officeDocument/2006/relationships" id="2147483671" r:id="Rc1c07383c90b4fc3"/>
-    <p:sldLayoutId xmlns:r="http://schemas.openxmlformats.org/officeDocument/2006/relationships" id="2147483672" r:id="R78b6cd39d3c248f6"/>
-    <p:sldLayoutId xmlns:r="http://schemas.openxmlformats.org/officeDocument/2006/relationships" id="2147483673" r:id="R25b89b10a0004e4c"/>
-    <p:sldLayoutId xmlns:r="http://schemas.openxmlformats.org/officeDocument/2006/relationships" id="2147483674" r:id="Re91be48614c74292"/>
-    <p:sldLayoutId xmlns:r="http://schemas.openxmlformats.org/officeDocument/2006/relationships" id="2147483675" r:id="R56a0f04e255c4466"/>
-    <p:sldLayoutId xmlns:r="http://schemas.openxmlformats.org/officeDocument/2006/relationships" id="2147483676" r:id="R9c12d29beb7b489f"/>
-    <p:sldLayoutId xmlns:r="http://schemas.openxmlformats.org/officeDocument/2006/relationships" id="2147483677" r:id="Reca442d49c2148f2"/>
-    <p:sldLayoutId xmlns:r="http://schemas.openxmlformats.org/officeDocument/2006/relationships" id="2147483678" r:id="R4f3d92b35f574566"/>
+    <p:sldLayoutId xmlns:r="http://schemas.openxmlformats.org/officeDocument/2006/relationships" id="2147483666" r:id="R92b7f82a91ca4051"/>
+    <p:sldLayoutId xmlns:r="http://schemas.openxmlformats.org/officeDocument/2006/relationships" id="2147483667" r:id="Rb9b89e204d3d4dcd"/>
+    <p:sldLayoutId xmlns:r="http://schemas.openxmlformats.org/officeDocument/2006/relationships" id="2147483668" r:id="Ra905f8726b27453d"/>
+    <p:sldLayoutId xmlns:r="http://schemas.openxmlformats.org/officeDocument/2006/relationships" id="2147483669" r:id="Rc637ba30ef91406d"/>
+    <p:sldLayoutId xmlns:r="http://schemas.openxmlformats.org/officeDocument/2006/relationships" id="2147483670" r:id="Rda8cd8fcb1cb4a09"/>
+    <p:sldLayoutId xmlns:r="http://schemas.openxmlformats.org/officeDocument/2006/relationships" id="2147483671" r:id="Racdabfdcadad4dac"/>
+    <p:sldLayoutId xmlns:r="http://schemas.openxmlformats.org/officeDocument/2006/relationships" id="2147483672" r:id="R20164493139e46d2"/>
+    <p:sldLayoutId xmlns:r="http://schemas.openxmlformats.org/officeDocument/2006/relationships" id="2147483673" r:id="R6d929edbf50d4c7d"/>
+    <p:sldLayoutId xmlns:r="http://schemas.openxmlformats.org/officeDocument/2006/relationships" id="2147483674" r:id="R6738698598584d79"/>
+    <p:sldLayoutId xmlns:r="http://schemas.openxmlformats.org/officeDocument/2006/relationships" id="2147483675" r:id="Rbc066c5e8da846ee"/>
+    <p:sldLayoutId xmlns:r="http://schemas.openxmlformats.org/officeDocument/2006/relationships" id="2147483676" r:id="R5ce7ad7961b34f24"/>
+    <p:sldLayoutId xmlns:r="http://schemas.openxmlformats.org/officeDocument/2006/relationships" id="2147483677" r:id="R7f1ffd43371048a8"/>
+    <p:sldLayoutId xmlns:r="http://schemas.openxmlformats.org/officeDocument/2006/relationships" id="2147483678" r:id="Rbd2be75ccd5a41fc"/>
   </p:sldLayoutIdLst>
   <p:hf hdr="0" ftr="0" dt="0"/>
   <p:txStyles>
@@ -29368,7 +29262,7 @@
           <a:lstStyle xmlns:a="http://schemas.openxmlformats.org/drawingml/2006/main"/>
           <a:p xmlns:a="http://schemas.openxmlformats.org/drawingml/2006/main">
             <a:r>
-              <a:t>Why this is useful to oneCCL at first glance</a:t>
+              <a:t>What the skill tells an agent today</a:t>
             </a:r>
           </a:p>
         </p:txBody>
@@ -29418,7 +29312,7 @@
                   <a:srgbClr val="000000"/>
                 </a:solidFill>
               </a:rPr>
-              <a:t> Prevent deadlocks before tuning</a:t>
+              <a:t> Identify the API surface</a:t>
             </a:r>
             <a:r>
               <a:rPr sz="1913">
@@ -29426,7 +29320,7 @@
                   <a:srgbClr val="000000"/>
                 </a:solidFill>
               </a:rPr>
-              <a:t> — Every rank must enter the same collective sequence with compatible buffers, counts, types, roots, and communicators.</a:t>
+              <a:t> — C++ API, NCCL-like C API, PyTorch DDP, Horovod, or framework wrapper.</a:t>
             </a:r>
           </a:p>
           <a:p xmlns:a="http://schemas.openxmlformats.org/drawingml/2006/main">
@@ -29447,7 +29341,7 @@
                   <a:srgbClr val="000000"/>
                 </a:solidFill>
               </a:rPr>
-              <a:t> Make async completion explicit</a:t>
+              <a:t> Match collective to semantics</a:t>
             </a:r>
             <a:r>
               <a:rPr sz="1913">
@@ -29455,7 +29349,7 @@
                   <a:srgbClr val="000000"/>
                 </a:solidFill>
               </a:rPr>
-              <a:t> — A submitted collective is not complete until waited or otherwise synchronized.</a:t>
+              <a:t> — Allreduce, allgather, alltoall, reduce-scatter, broadcast, point-to-point, or grouped calls.</a:t>
             </a:r>
           </a:p>
           <a:p xmlns:a="http://schemas.openxmlformats.org/drawingml/2006/main">
@@ -29476,7 +29370,7 @@
                   <a:srgbClr val="000000"/>
                 </a:solidFill>
               </a:rPr>
-              <a:t> Collect evidence per rank</a:t>
+              <a:t> Validate rank symmetry</a:t>
             </a:r>
             <a:r>
               <a:rPr sz="1913">
@@ -29484,7 +29378,7 @@
                   <a:srgbClr val="000000"/>
                 </a:solidFill>
               </a:rPr>
-              <a:t> — Launch command, mapping, plugin, transport, environment, entry/submission/wait logs, and minimal reproducer.</a:t>
+              <a:t> — Collective order, buffer sizes, datatypes, roots, reductions, and communicator membership.</a:t>
             </a:r>
           </a:p>
           <a:p xmlns:a="http://schemas.openxmlformats.org/drawingml/2006/main">
@@ -29505,7 +29399,7 @@
                   <a:srgbClr val="000000"/>
                 </a:solidFill>
               </a:rPr>
-              <a:t> Separate correctness from transport tuning</a:t>
+              <a:t> Handle zero counts safely</a:t>
             </a:r>
             <a:r>
               <a:rPr sz="1913">
@@ -29513,7 +29407,36 @@
                   <a:srgbClr val="000000"/>
                 </a:solidFill>
               </a:rPr>
-              <a:t> — Worker count, affinity, plugin, and transport change only after launch symmetry is proven.</a:t>
+              <a:t> — Represent empty peer segments without one-past device pointers, including in-place temporaries.</a:t>
+            </a:r>
+          </a:p>
+          <a:p xmlns:a="http://schemas.openxmlformats.org/drawingml/2006/main">
+            <a:pPr marL="30" indent="-18">
+              <a:spcAft>
+                <a:spcPts val="10"/>
+              </a:spcAft>
+              <a:buChar char="•"/>
+              <a:defRPr sz="1913">
+                <a:solidFill>
+                  <a:srgbClr val="000000"/>
+                </a:solidFill>
+              </a:defRPr>
+            </a:pPr>
+            <a:r>
+              <a:rPr sz="1913" b="1">
+                <a:solidFill>
+                  <a:srgbClr val="000000"/>
+                </a:solidFill>
+              </a:rPr>
+              <a:t> Reduce hangs deliberately</a:t>
+            </a:r>
+            <a:r>
+              <a:rPr sz="1913">
+                <a:solidFill>
+                  <a:srgbClr val="000000"/>
+                </a:solidFill>
+              </a:rPr>
+              <a:t> — Two ranks, one small tensor, one collective, and logs around entry/submission/wait.</a:t>
             </a:r>
           </a:p>
         </p:txBody>
@@ -29605,7 +29528,7 @@
           <a:lstStyle xmlns:a="http://schemas.openxmlformats.org/drawingml/2006/main"/>
           <a:p xmlns:a="http://schemas.openxmlformats.org/drawingml/2006/main">
             <a:r>
-              <a:t>What the skill tells an agent today</a:t>
+              <a:t>Evaluation inventory: 5 implemented, 2 distributed gaps</a:t>
             </a:r>
           </a:p>
         </p:txBody>
@@ -29655,7 +29578,7 @@
                   <a:srgbClr val="000000"/>
                 </a:solidFill>
               </a:rPr>
-              <a:t> Identify the API surface</a:t>
+              <a:t> Implemented</a:t>
             </a:r>
             <a:r>
               <a:rPr sz="1913">
@@ -29663,7 +29586,7 @@
                   <a:srgbClr val="000000"/>
                 </a:solidFill>
               </a:rPr>
-              <a:t> — C++ API, NCCL-like C API, PyTorch DDP, Horovod, or framework wrapper.</a:t>
+              <a:t> — Async allreduce wait; divergent collective sequence; datatype/count mismatch; C++ versus NCCL-like API; zero-count topo alltoallv.</a:t>
             </a:r>
           </a:p>
           <a:p xmlns:a="http://schemas.openxmlformats.org/drawingml/2006/main">
@@ -29684,7 +29607,7 @@
                   <a:srgbClr val="000000"/>
                 </a:solidFill>
               </a:rPr>
-              <a:t> Match collective to semantics</a:t>
+              <a:t> Incident evidence</a:t>
             </a:r>
             <a:r>
               <a:rPr sz="1913">
@@ -29692,7 +29615,7 @@
                   <a:srgbClr val="000000"/>
                 </a:solidFill>
               </a:rPr>
-              <a:t> — Allreduce, allgather, alltoall, reduce-scatter, broadcast, point-to-point, or grouped calls.</a:t>
+              <a:t> — The zero-count task checks the accepted repair boundary from upstream issue #174.</a:t>
             </a:r>
           </a:p>
           <a:p xmlns:a="http://schemas.openxmlformats.org/drawingml/2006/main">
@@ -29713,7 +29636,7 @@
                   <a:srgbClr val="000000"/>
                 </a:solidFill>
               </a:rPr>
-              <a:t> Validate rank symmetry</a:t>
+              <a:t> Planned</a:t>
             </a:r>
             <a:r>
               <a:rPr sz="1913">
@@ -29721,7 +29644,7 @@
                   <a:srgbClr val="000000"/>
                 </a:solidFill>
               </a:rPr>
-              <a:t> — Collective order, buffer sizes, datatypes, roots, reductions, and communicator membership.</a:t>
+              <a:t> — Plugin rank visibility and worker-affinity regression on a stable distributed target.</a:t>
             </a:r>
           </a:p>
           <a:p xmlns:a="http://schemas.openxmlformats.org/drawingml/2006/main">
@@ -29742,7 +29665,7 @@
                   <a:srgbClr val="000000"/>
                 </a:solidFill>
               </a:rPr>
-              <a:t> Handle zero counts safely</a:t>
+              <a:t> Evidence boundary</a:t>
             </a:r>
             <a:r>
               <a:rPr sz="1913">
@@ -29750,36 +29673,7 @@
                   <a:srgbClr val="000000"/>
                 </a:solidFill>
               </a:rPr>
-              <a:t> — Represent empty peer segments without one-past device pointers, including in-place temporaries.</a:t>
-            </a:r>
-          </a:p>
-          <a:p xmlns:a="http://schemas.openxmlformats.org/drawingml/2006/main">
-            <a:pPr marL="30" indent="-18">
-              <a:spcAft>
-                <a:spcPts val="10"/>
-              </a:spcAft>
-              <a:buChar char="•"/>
-              <a:defRPr sz="1913">
-                <a:solidFill>
-                  <a:srgbClr val="000000"/>
-                </a:solidFill>
-              </a:defRPr>
-            </a:pPr>
-            <a:r>
-              <a:rPr sz="1913" b="1">
-                <a:solidFill>
-                  <a:srgbClr val="000000"/>
-                </a:solidFill>
-              </a:rPr>
-              <a:t> Reduce hangs deliberately</a:t>
-            </a:r>
-            <a:r>
-              <a:rPr sz="1913">
-                <a:solidFill>
-                  <a:srgbClr val="000000"/>
-                </a:solidFill>
-              </a:rPr>
-              <a:t> — Two ranks, one small tensor, one collective, and logs around entry/submission/wait.</a:t>
+              <a:t> — The current fixture does not reproduce the original Aurora/Level Zero failure and must not be presented as hardware qualification.</a:t>
             </a:r>
           </a:p>
         </p:txBody>
@@ -29871,7 +29765,7 @@
           <a:lstStyle xmlns:a="http://schemas.openxmlformats.org/drawingml/2006/main"/>
           <a:p xmlns:a="http://schemas.openxmlformats.org/drawingml/2006/main">
             <a:r>
-              <a:t>Evaluation inventory: 5 implemented, 2 distributed gaps</a:t>
+              <a:t>How we chose the content</a:t>
             </a:r>
           </a:p>
         </p:txBody>
@@ -29921,7 +29815,7 @@
                   <a:srgbClr val="000000"/>
                 </a:solidFill>
               </a:rPr>
-              <a:t> Implemented</a:t>
+              <a:t> Official sources</a:t>
             </a:r>
             <a:r>
               <a:rPr sz="1913">
@@ -29929,7 +29823,7 @@
                   <a:srgbClr val="000000"/>
                 </a:solidFill>
               </a:rPr>
-              <a:t> — Async allreduce wait; divergent collective sequence; datatype/count mismatch; C++ versus NCCL-like API; zero-count topo alltoallv.</a:t>
+              <a:t> — Project docs, examples, launch guidance, plugins, integrations, releases, and issue evidence.</a:t>
             </a:r>
           </a:p>
           <a:p xmlns:a="http://schemas.openxmlformats.org/drawingml/2006/main">
@@ -29950,7 +29844,7 @@
                   <a:srgbClr val="000000"/>
                 </a:solidFill>
               </a:rPr>
-              <a:t> Incident evidence</a:t>
+              <a:t> Common distributed failure structure</a:t>
             </a:r>
             <a:r>
               <a:rPr sz="1913">
@@ -29958,7 +29852,7 @@
                   <a:srgbClr val="000000"/>
                 </a:solidFill>
               </a:rPr>
-              <a:t> — The zero-count task checks the accepted repair boundary from upstream issue #174.</a:t>
+              <a:t> — Asymmetric calls, waits, buffer/count mismatches, rank mapping, plugin visibility, and hidden framework collectives.</a:t>
             </a:r>
           </a:p>
           <a:p xmlns:a="http://schemas.openxmlformats.org/drawingml/2006/main">
@@ -29979,7 +29873,7 @@
                   <a:srgbClr val="000000"/>
                 </a:solidFill>
               </a:rPr>
-              <a:t> Planned</a:t>
+              <a:t> Minimal executable tasks</a:t>
             </a:r>
             <a:r>
               <a:rPr sz="1913">
@@ -29987,7 +29881,7 @@
                   <a:srgbClr val="000000"/>
                 </a:solidFill>
               </a:rPr>
-              <a:t> — Plugin rank visibility and worker-affinity regression on a stable distributed target.</a:t>
+              <a:t> — Hosted fixtures check reasoning and repair contracts where real multi-rank hardware is not required.</a:t>
             </a:r>
           </a:p>
           <a:p xmlns:a="http://schemas.openxmlformats.org/drawingml/2006/main">
@@ -30008,7 +29902,7 @@
                   <a:srgbClr val="000000"/>
                 </a:solidFill>
               </a:rPr>
-              <a:t> Evidence boundary</a:t>
+              <a:t> Visible infrastructure gaps</a:t>
             </a:r>
             <a:r>
               <a:rPr sz="1913">
@@ -30016,7 +29910,7 @@
                   <a:srgbClr val="000000"/>
                 </a:solidFill>
               </a:rPr>
-              <a:t> — The current fixture does not reproduce the original Aurora/Level Zero failure and must not be presented as hardware qualification.</a:t>
+              <a:t> — Distributed plugin and affinity work stays planned until a faithful lane and provenance exist.</a:t>
             </a:r>
           </a:p>
         </p:txBody>
@@ -30108,7 +30002,7 @@
           <a:lstStyle xmlns:a="http://schemas.openxmlformats.org/drawingml/2006/main"/>
           <a:p xmlns:a="http://schemas.openxmlformats.org/drawingml/2006/main">
             <a:r>
-              <a:t>How we chose the content</a:t>
+              <a:t>What project ownership would look like</a:t>
             </a:r>
           </a:p>
         </p:txBody>
@@ -30158,7 +30052,7 @@
                   <a:srgbClr val="000000"/>
                 </a:solidFill>
               </a:rPr>
-              <a:t> Official sources</a:t>
+              <a:t> Review launch and API guidance</a:t>
             </a:r>
             <a:r>
               <a:rPr sz="1913">
@@ -30166,7 +30060,7 @@
                   <a:srgbClr val="000000"/>
                 </a:solidFill>
               </a:rPr>
-              <a:t> — Project docs, examples, launch guidance, plugins, integrations, releases, and issue evidence.</a:t>
+              <a:t> — Especially current C API status, GPU/plugin behavior, framework integration, and environment conventions.</a:t>
             </a:r>
           </a:p>
           <a:p xmlns:a="http://schemas.openxmlformats.org/drawingml/2006/main">
@@ -30187,7 +30081,7 @@
                   <a:srgbClr val="000000"/>
                 </a:solidFill>
               </a:rPr>
-              <a:t> Common distributed failure structure</a:t>
+              <a:t> Validate hang-triage order</a:t>
             </a:r>
             <a:r>
               <a:rPr sz="1913">
@@ -30195,7 +30089,7 @@
                   <a:srgbClr val="000000"/>
                 </a:solidFill>
               </a:rPr>
-              <a:t> — Asymmetric calls, waits, buffer/count mismatches, rank mapping, plugin visibility, and hidden framework collectives.</a:t>
+              <a:t> — Ensure the evidence sequence matches how maintainers actually debug incidents.</a:t>
             </a:r>
           </a:p>
           <a:p xmlns:a="http://schemas.openxmlformats.org/drawingml/2006/main">
@@ -30216,7 +30110,7 @@
                   <a:srgbClr val="000000"/>
                 </a:solidFill>
               </a:rPr>
-              <a:t> Minimal executable tasks</a:t>
+              <a:t> Supply authentic distributed cases</a:t>
             </a:r>
             <a:r>
               <a:rPr sz="1913">
@@ -30224,7 +30118,7 @@
                   <a:srgbClr val="000000"/>
                 </a:solidFill>
               </a:rPr>
-              <a:t> — Hosted fixtures check reasoning and repair contracts where real multi-rank hardware is not required.</a:t>
+              <a:t> — The highest-value next step is a reproducible plugin or rank-visibility incident.</a:t>
             </a:r>
           </a:p>
           <a:p xmlns:a="http://schemas.openxmlformats.org/drawingml/2006/main">
@@ -30245,7 +30139,7 @@
                   <a:srgbClr val="000000"/>
                 </a:solidFill>
               </a:rPr>
-              <a:t> Visible infrastructure gaps</a:t>
+              <a:t> UXL keeps the machinery</a:t>
             </a:r>
             <a:r>
               <a:rPr sz="1913">
@@ -30253,7 +30147,7 @@
                   <a:srgbClr val="000000"/>
                 </a:solidFill>
               </a:rPr>
-              <a:t> — Distributed plugin and affinity work stays planned until a faithful lane and provenance exist.</a:t>
+              <a:t> — Common evaluator policy, hosted fixtures, dashboards, artifact retention, and runner contracts.</a:t>
             </a:r>
           </a:p>
         </p:txBody>
@@ -30345,243 +30239,6 @@
           <a:lstStyle xmlns:a="http://schemas.openxmlformats.org/drawingml/2006/main"/>
           <a:p xmlns:a="http://schemas.openxmlformats.org/drawingml/2006/main">
             <a:r>
-              <a:t>What project ownership would look like</a:t>
-            </a:r>
-          </a:p>
-        </p:txBody>
-      </p:sp>
-      <p:sp>
-        <p:nvSpPr>
-          <p:cNvPr id="3" name="Content Placeholder 2">
-            <a:extLst xmlns:a="http://schemas.openxmlformats.org/drawingml/2006/main">
-              <a:ext uri="{FF2B5EF4-FFF2-40B4-BE49-F238E27FC236}">
-                <a16:creationId xmlns:a16="http://schemas.microsoft.com/office/drawing/2014/main" id="{ECF5C9F1-2691-0BC9-F1E1-01CECB857FE3}"/>
-              </a:ext>
-            </a:extLst>
-          </p:cNvPr>
-          <p:cNvSpPr>
-            <a:spLocks xmlns:a="http://schemas.openxmlformats.org/drawingml/2006/main" noGrp="1"/>
-          </p:cNvSpPr>
-          <p:nvPr>
-            <p:ph type="body" idx="1"/>
-          </p:nvPr>
-        </p:nvSpPr>
-        <p:spPr>
-          <a:xfrm xmlns:a="http://schemas.openxmlformats.org/drawingml/2006/main">
-            <a:off x="838200" y="1825625"/>
-            <a:ext cx="10515600" cy="4351200"/>
-          </a:xfrm>
-        </p:spPr>
-        <p:txBody>
-          <a:bodyPr xmlns:a="http://schemas.openxmlformats.org/drawingml/2006/main" wrap="square" anchor="t">
-            <a:normAutofit fontScale="100000"/>
-          </a:bodyPr>
-          <a:lstStyle xmlns:a="http://schemas.openxmlformats.org/drawingml/2006/main"/>
-          <a:p xmlns:a="http://schemas.openxmlformats.org/drawingml/2006/main">
-            <a:pPr marL="30" indent="-18">
-              <a:spcAft>
-                <a:spcPts val="10"/>
-              </a:spcAft>
-              <a:buChar char="•"/>
-              <a:defRPr sz="1913">
-                <a:solidFill>
-                  <a:srgbClr val="000000"/>
-                </a:solidFill>
-              </a:defRPr>
-            </a:pPr>
-            <a:r>
-              <a:rPr sz="1913" b="1">
-                <a:solidFill>
-                  <a:srgbClr val="000000"/>
-                </a:solidFill>
-              </a:rPr>
-              <a:t> Review launch and API guidance</a:t>
-            </a:r>
-            <a:r>
-              <a:rPr sz="1913">
-                <a:solidFill>
-                  <a:srgbClr val="000000"/>
-                </a:solidFill>
-              </a:rPr>
-              <a:t> — Especially current C API status, GPU/plugin behavior, framework integration, and environment conventions.</a:t>
-            </a:r>
-          </a:p>
-          <a:p xmlns:a="http://schemas.openxmlformats.org/drawingml/2006/main">
-            <a:pPr marL="30" indent="-18">
-              <a:spcAft>
-                <a:spcPts val="10"/>
-              </a:spcAft>
-              <a:buChar char="•"/>
-              <a:defRPr sz="1913">
-                <a:solidFill>
-                  <a:srgbClr val="000000"/>
-                </a:solidFill>
-              </a:defRPr>
-            </a:pPr>
-            <a:r>
-              <a:rPr sz="1913" b="1">
-                <a:solidFill>
-                  <a:srgbClr val="000000"/>
-                </a:solidFill>
-              </a:rPr>
-              <a:t> Validate hang-triage order</a:t>
-            </a:r>
-            <a:r>
-              <a:rPr sz="1913">
-                <a:solidFill>
-                  <a:srgbClr val="000000"/>
-                </a:solidFill>
-              </a:rPr>
-              <a:t> — Ensure the evidence sequence matches how maintainers actually debug incidents.</a:t>
-            </a:r>
-          </a:p>
-          <a:p xmlns:a="http://schemas.openxmlformats.org/drawingml/2006/main">
-            <a:pPr marL="30" indent="-18">
-              <a:spcAft>
-                <a:spcPts val="10"/>
-              </a:spcAft>
-              <a:buChar char="•"/>
-              <a:defRPr sz="1913">
-                <a:solidFill>
-                  <a:srgbClr val="000000"/>
-                </a:solidFill>
-              </a:defRPr>
-            </a:pPr>
-            <a:r>
-              <a:rPr sz="1913" b="1">
-                <a:solidFill>
-                  <a:srgbClr val="000000"/>
-                </a:solidFill>
-              </a:rPr>
-              <a:t> Supply authentic distributed cases</a:t>
-            </a:r>
-            <a:r>
-              <a:rPr sz="1913">
-                <a:solidFill>
-                  <a:srgbClr val="000000"/>
-                </a:solidFill>
-              </a:rPr>
-              <a:t> — The highest-value next step is a reproducible plugin or rank-visibility incident.</a:t>
-            </a:r>
-          </a:p>
-          <a:p xmlns:a="http://schemas.openxmlformats.org/drawingml/2006/main">
-            <a:pPr marL="30" indent="-18">
-              <a:spcAft>
-                <a:spcPts val="10"/>
-              </a:spcAft>
-              <a:buChar char="•"/>
-              <a:defRPr sz="1913">
-                <a:solidFill>
-                  <a:srgbClr val="000000"/>
-                </a:solidFill>
-              </a:defRPr>
-            </a:pPr>
-            <a:r>
-              <a:rPr sz="1913" b="1">
-                <a:solidFill>
-                  <a:srgbClr val="000000"/>
-                </a:solidFill>
-              </a:rPr>
-              <a:t> UXL keeps the machinery</a:t>
-            </a:r>
-            <a:r>
-              <a:rPr sz="1913">
-                <a:solidFill>
-                  <a:srgbClr val="000000"/>
-                </a:solidFill>
-              </a:rPr>
-              <a:t> — Common evaluator policy, hosted fixtures, dashboards, artifact retention, and runner contracts.</a:t>
-            </a:r>
-          </a:p>
-        </p:txBody>
-      </p:sp>
-      <p:sp>
-        <p:nvSpPr>
-          <p:cNvPr id="7" name="TextBox 6">
-            <a:extLst xmlns:a="http://schemas.openxmlformats.org/drawingml/2006/main">
-              <a:ext uri="{FF2B5EF4-FFF2-40B4-BE49-F238E27FC236}">
-                <a16:creationId xmlns:a16="http://schemas.microsoft.com/office/drawing/2014/main" id="{E2E6F043-0F84-54F7-A567-6E5851801779}"/>
-              </a:ext>
-            </a:extLst>
-          </p:cNvPr>
-          <p:cNvSpPr>
-            <a:spLocks xmlns:a="http://schemas.openxmlformats.org/drawingml/2006/main" noGrp="1"/>
-          </p:cNvSpPr>
-          <p:nvPr/>
-        </p:nvSpPr>
-        <p:spPr>
-          <a:xfrm xmlns:a="http://schemas.openxmlformats.org/drawingml/2006/main">
-            <a:off x="696174" y="6338986"/>
-            <a:ext cx="284052" cy="307777"/>
-          </a:xfrm>
-          <a:prstGeom xmlns:a="http://schemas.openxmlformats.org/drawingml/2006/main" prst="rect">
-            <a:avLst/>
-          </a:prstGeom>
-          <a:noFill xmlns:a="http://schemas.openxmlformats.org/drawingml/2006/main"/>
-        </p:spPr>
-        <p:txBody>
-          <a:bodyPr xmlns:a="http://schemas.openxmlformats.org/drawingml/2006/main" wrap="none">
-            <a:spAutoFit/>
-          </a:bodyPr>
-          <a:lstStyle xmlns:a="http://schemas.openxmlformats.org/drawingml/2006/main"/>
-          <a:p xmlns:a="http://schemas.openxmlformats.org/drawingml/2006/main">
-            <a:r>
-              <a:t>6</a:t>
-            </a:r>
-          </a:p>
-        </p:txBody>
-      </p:sp>
-    </p:spTree>
-    <p:extLst>
-      <p:ext uri="{BB962C8B-B14F-4D97-AF65-F5344CB8AC3E}">
-        <p14:creationId xmlns:p14="http://schemas.microsoft.com/office/powerpoint/2010/main" val="1742728663"/>
-      </p:ext>
-    </p:extLst>
-  </p:cSld>
-</p:sld>
-</file>
-
-<file path=ppt/slides/slide7.xml><?xml version="1.0" encoding="utf-8"?>
-<p:sld xmlns:p="http://schemas.openxmlformats.org/presentationml/2006/main">
-  <p:cSld>
-    <p:spTree>
-      <p:nvGrpSpPr>
-        <p:cNvPr id="1" name=""/>
-        <p:cNvGrpSpPr/>
-        <p:nvPr/>
-      </p:nvGrpSpPr>
-      <p:grpSpPr>
-        <a:xfrm xmlns:a="http://schemas.openxmlformats.org/drawingml/2006/main"/>
-      </p:grpSpPr>
-      <p:sp>
-        <p:nvSpPr>
-          <p:cNvPr id="2" name="Title 1">
-            <a:extLst xmlns:a="http://schemas.openxmlformats.org/drawingml/2006/main">
-              <a:ext uri="{FF2B5EF4-FFF2-40B4-BE49-F238E27FC236}">
-                <a16:creationId xmlns:a16="http://schemas.microsoft.com/office/drawing/2014/main" id="{F64C2A24-546D-C55C-2C52-97A4957F67E0}"/>
-              </a:ext>
-            </a:extLst>
-          </p:cNvPr>
-          <p:cNvSpPr>
-            <a:spLocks xmlns:a="http://schemas.openxmlformats.org/drawingml/2006/main" noGrp="1"/>
-          </p:cNvSpPr>
-          <p:nvPr>
-            <p:ph type="title" idx="0"/>
-          </p:nvPr>
-        </p:nvSpPr>
-        <p:spPr>
-          <a:xfrm xmlns:a="http://schemas.openxmlformats.org/drawingml/2006/main">
-            <a:off x="838200" y="365125"/>
-            <a:ext cx="10515600" cy="1325700"/>
-          </a:xfrm>
-        </p:spPr>
-        <p:txBody>
-          <a:bodyPr xmlns:a="http://schemas.openxmlformats.org/drawingml/2006/main">
-            <a:normAutofit fontScale="100000"/>
-          </a:bodyPr>
-          <a:lstStyle xmlns:a="http://schemas.openxmlformats.org/drawingml/2006/main"/>
-          <a:p xmlns:a="http://schemas.openxmlformats.org/drawingml/2006/main">
-            <a:r>
               <a:t>A focused 30-minute maintainer review</a:t>
             </a:r>
           </a:p>
@@ -30792,7 +30449,7 @@
           <a:lstStyle xmlns:a="http://schemas.openxmlformats.org/drawingml/2006/main"/>
           <a:p xmlns:a="http://schemas.openxmlformats.org/drawingml/2006/main">
             <a:r>
-              <a:t>7</a:t>
+              <a:t>6</a:t>
             </a:r>
           </a:p>
         </p:txBody>

</xml_diff>

<commit_message>
docs: add descriptive notes to maintainer decks
</commit_message>
<xml_diff>
--- a/evaluation/dashboard/public/decks/uxl-oneccl-maintainer-briefing.pptx
+++ b/evaluation/dashboard/public/decks/uxl-oneccl-maintainer-briefing.pptx
@@ -2,19 +2,19 @@
 <file path=ppt/presentation.xml><?xml version="1.0" encoding="utf-8"?>
 <p:presentation xmlns:p="http://schemas.openxmlformats.org/presentationml/2006/main">
   <p:sldMasterIdLst>
-    <p:sldMasterId xmlns:r="http://schemas.openxmlformats.org/officeDocument/2006/relationships" id="2147483648" r:id="Re0e0fd93dc0f4a1b"/>
-    <p:sldMasterId xmlns:r="http://schemas.openxmlformats.org/officeDocument/2006/relationships" id="2147483665" r:id="Rf01571311831434a"/>
+    <p:sldMasterId xmlns:r="http://schemas.openxmlformats.org/officeDocument/2006/relationships" id="2147483648" r:id="R06e5b3a630e74782"/>
+    <p:sldMasterId xmlns:r="http://schemas.openxmlformats.org/officeDocument/2006/relationships" id="2147483665" r:id="R7eb92f309aef4b9e"/>
   </p:sldMasterIdLst>
   <p:notesMasterIdLst>
-    <p:notesMasterId xmlns:r="http://schemas.openxmlformats.org/officeDocument/2006/relationships" r:id="R57bb29e9678c4f5c"/>
+    <p:notesMasterId xmlns:r="http://schemas.openxmlformats.org/officeDocument/2006/relationships" r:id="R15ec40a31d9f4b8c"/>
   </p:notesMasterIdLst>
   <p:sldIdLst>
-    <p:sldId xmlns:r="http://schemas.openxmlformats.org/officeDocument/2006/relationships" id="256" r:id="R38123e27fbeb4381"/>
-    <p:sldId xmlns:r="http://schemas.openxmlformats.org/officeDocument/2006/relationships" id="257" r:id="R3d30f4742126454d"/>
-    <p:sldId xmlns:r="http://schemas.openxmlformats.org/officeDocument/2006/relationships" id="258" r:id="Rabe0f841331d4f03"/>
-    <p:sldId xmlns:r="http://schemas.openxmlformats.org/officeDocument/2006/relationships" id="259" r:id="Rb74f31b3cbd142b8"/>
-    <p:sldId xmlns:r="http://schemas.openxmlformats.org/officeDocument/2006/relationships" id="260" r:id="Ref29dc64ad704671"/>
-    <p:sldId xmlns:r="http://schemas.openxmlformats.org/officeDocument/2006/relationships" id="261" r:id="Rdfafb0dda9854911"/>
+    <p:sldId xmlns:r="http://schemas.openxmlformats.org/officeDocument/2006/relationships" id="256" r:id="Ra1a739765fc241dd"/>
+    <p:sldId xmlns:r="http://schemas.openxmlformats.org/officeDocument/2006/relationships" id="257" r:id="R26ac5204e40c41fc"/>
+    <p:sldId xmlns:r="http://schemas.openxmlformats.org/officeDocument/2006/relationships" id="258" r:id="Rea7e398f7af44418"/>
+    <p:sldId xmlns:r="http://schemas.openxmlformats.org/officeDocument/2006/relationships" id="259" r:id="Rfae159ccac8647ee"/>
+    <p:sldId xmlns:r="http://schemas.openxmlformats.org/officeDocument/2006/relationships" id="260" r:id="R6e0f8413fe5c4732"/>
+    <p:sldId xmlns:r="http://schemas.openxmlformats.org/officeDocument/2006/relationships" id="261" r:id="Re95f8130298a40dd"/>
   </p:sldIdLst>
   <p:sldSz cx="12192000" cy="6858000"/>
   <p:notesSz cx="6858000" cy="9144000"/>
@@ -493,12 +493,17 @@
           </a:p>
           <a:p xmlns:a="http://schemas.openxmlformats.org/drawingml/2006/main">
             <a:r>
-              <a:t>- https://github.com/uxlfoundation/skills/blob/main/evaluation/harbor/results/2026-08-27-oneccl-zero-count-fixture.md</a:t>
+              <a:t>- https://github.com/uxlfoundation/skills/blob/main/docs/maintainer-review/uxl-oneccl.md</a:t>
             </a:r>
           </a:p>
           <a:p xmlns:a="http://schemas.openxmlformats.org/drawingml/2006/main">
             <a:r>
               <a:t>- https://github.com/uxlfoundation/skills/blob/main/evaluation/harbor/suites.json</a:t>
+            </a:r>
+          </a:p>
+          <a:p xmlns:a="http://schemas.openxmlformats.org/drawingml/2006/main">
+            <a:r>
+              <a:t>- https://github.com/uxlfoundation/skills/blob/main/evaluation/harbor/EVALUATOR_POLICY.md</a:t>
             </a:r>
           </a:p>
           <a:p xmlns:a="http://schemas.openxmlformats.org/drawingml/2006/main">
@@ -513,7 +518,22 @@
           </a:p>
           <a:p xmlns:a="http://schemas.openxmlformats.org/drawingml/2006/main">
             <a:r>
-              <a:t>Speaker cue: oneCCL skill: make distributed failures diagnosable</a:t>
+              <a:t>Presenter guidance</a:t>
+            </a:r>
+          </a:p>
+          <a:p xmlns:a="http://schemas.openxmlformats.org/drawingml/2006/main">
+            <a:r>
+              <a:t>Purpose: Introduce the draft oneCCL skill and its current evaluation coverage.</a:t>
+            </a:r>
+          </a:p>
+          <a:p xmlns:a="http://schemas.openxmlformats.org/drawingml/2006/main">
+            <a:r>
+              <a:t>Explain: The skill helps coding agents reason about collective contracts, rank agreement, operation ordering, counts and datatypes, completion waits, plugin selection, and rank-local diagnosis.</a:t>
+            </a:r>
+          </a:p>
+          <a:p xmlns:a="http://schemas.openxmlformats.org/drawingml/2006/main">
+            <a:r>
+              <a:t>Emphasize: This is a UXL-authored starting point awaiting project review, not approved maintainer guidance.</a:t>
             </a:r>
           </a:p>
         </p:txBody>
@@ -598,12 +618,17 @@
           </a:p>
           <a:p xmlns:a="http://schemas.openxmlformats.org/drawingml/2006/main">
             <a:r>
-              <a:t>- https://github.com/uxlfoundation/skills/blob/main/evaluation/harbor/results/2026-08-27-oneccl-zero-count-fixture.md</a:t>
+              <a:t>- https://github.com/uxlfoundation/skills/blob/main/docs/maintainer-review/uxl-oneccl.md</a:t>
             </a:r>
           </a:p>
           <a:p xmlns:a="http://schemas.openxmlformats.org/drawingml/2006/main">
             <a:r>
               <a:t>- https://github.com/uxlfoundation/skills/blob/main/evaluation/harbor/suites.json</a:t>
+            </a:r>
+          </a:p>
+          <a:p xmlns:a="http://schemas.openxmlformats.org/drawingml/2006/main">
+            <a:r>
+              <a:t>- https://github.com/uxlfoundation/skills/blob/main/evaluation/harbor/EVALUATOR_POLICY.md</a:t>
             </a:r>
           </a:p>
           <a:p xmlns:a="http://schemas.openxmlformats.org/drawingml/2006/main">
@@ -618,7 +643,22 @@
           </a:p>
           <a:p xmlns:a="http://schemas.openxmlformats.org/drawingml/2006/main">
             <a:r>
-              <a:t>Speaker cue: What the skill tells an agent today</a:t>
+              <a:t>Presenter guidance</a:t>
+            </a:r>
+          </a:p>
+          <a:p xmlns:a="http://schemas.openxmlformats.org/drawingml/2006/main">
+            <a:r>
+              <a:t>Purpose: Walk through the behavior the skill asks an agent to follow today.</a:t>
+            </a:r>
+          </a:p>
+          <a:p xmlns:a="http://schemas.openxmlformats.org/drawingml/2006/main">
+            <a:r>
+              <a:t>Explain: The intended sequence is to make every rank's contract explicit, capture rank-local evidence, wait for completion before reading results, and isolate API, version, transport, and plugin assumptions.</a:t>
+            </a:r>
+          </a:p>
+          <a:p xmlns:a="http://schemas.openxmlformats.org/drawingml/2006/main">
+            <a:r>
+              <a:t>Emphasize: A useful answer ends with reproducible evidence and a clear failure classification, not a plausible-looking command alone.</a:t>
             </a:r>
           </a:p>
         </p:txBody>
@@ -703,12 +743,17 @@
           </a:p>
           <a:p xmlns:a="http://schemas.openxmlformats.org/drawingml/2006/main">
             <a:r>
-              <a:t>- https://github.com/uxlfoundation/skills/blob/main/evaluation/harbor/results/2026-08-27-oneccl-zero-count-fixture.md</a:t>
+              <a:t>- https://github.com/uxlfoundation/skills/blob/main/docs/maintainer-review/uxl-oneccl.md</a:t>
             </a:r>
           </a:p>
           <a:p xmlns:a="http://schemas.openxmlformats.org/drawingml/2006/main">
             <a:r>
               <a:t>- https://github.com/uxlfoundation/skills/blob/main/evaluation/harbor/suites.json</a:t>
+            </a:r>
+          </a:p>
+          <a:p xmlns:a="http://schemas.openxmlformats.org/drawingml/2006/main">
+            <a:r>
+              <a:t>- https://github.com/uxlfoundation/skills/blob/main/evaluation/harbor/EVALUATOR_POLICY.md</a:t>
             </a:r>
           </a:p>
           <a:p xmlns:a="http://schemas.openxmlformats.org/drawingml/2006/main">
@@ -723,7 +768,22 @@
           </a:p>
           <a:p xmlns:a="http://schemas.openxmlformats.org/drawingml/2006/main">
             <a:r>
-              <a:t>Speaker cue: Evaluation inventory: 5 implemented, 2 distributed gaps</a:t>
+              <a:t>Presenter guidance</a:t>
+            </a:r>
+          </a:p>
+          <a:p xmlns:a="http://schemas.openxmlformats.org/drawingml/2006/main">
+            <a:r>
+              <a:t>Purpose: Separate evaluation inventory from evidence that the skill improves outcomes.</a:t>
+            </a:r>
+          </a:p>
+          <a:p xmlns:a="http://schemas.openxmlformats.org/drawingml/2006/main">
+            <a:r>
+              <a:t>Explain: 5 of 7 evaluation tasks are implemented; five runnable scenarios cover core collective contracts, including a real zero-count fixture; multi-node and device-dependent cases remain planned.</a:t>
+            </a:r>
+          </a:p>
+          <a:p xmlns:a="http://schemas.openxmlformats.org/drawingml/2006/main">
+            <a:r>
+              <a:t>Emphasize: Implemented means the task can run. It does not mean the task passes, discriminates between treatments, or supports a promotion claim.</a:t>
             </a:r>
           </a:p>
         </p:txBody>
@@ -808,12 +868,17 @@
           </a:p>
           <a:p xmlns:a="http://schemas.openxmlformats.org/drawingml/2006/main">
             <a:r>
-              <a:t>- https://github.com/uxlfoundation/skills/blob/main/evaluation/harbor/results/2026-08-27-oneccl-zero-count-fixture.md</a:t>
+              <a:t>- https://github.com/uxlfoundation/skills/blob/main/docs/maintainer-review/uxl-oneccl.md</a:t>
             </a:r>
           </a:p>
           <a:p xmlns:a="http://schemas.openxmlformats.org/drawingml/2006/main">
             <a:r>
               <a:t>- https://github.com/uxlfoundation/skills/blob/main/evaluation/harbor/suites.json</a:t>
+            </a:r>
+          </a:p>
+          <a:p xmlns:a="http://schemas.openxmlformats.org/drawingml/2006/main">
+            <a:r>
+              <a:t>- https://github.com/uxlfoundation/skills/blob/main/evaluation/harbor/EVALUATOR_POLICY.md</a:t>
             </a:r>
           </a:p>
           <a:p xmlns:a="http://schemas.openxmlformats.org/drawingml/2006/main">
@@ -828,7 +893,22 @@
           </a:p>
           <a:p xmlns:a="http://schemas.openxmlformats.org/drawingml/2006/main">
             <a:r>
-              <a:t>Speaker cue: How we chose the content</a:t>
+              <a:t>Presenter guidance</a:t>
+            </a:r>
+          </a:p>
+          <a:p xmlns:a="http://schemas.openxmlformats.org/drawingml/2006/main">
+            <a:r>
+              <a:t>Purpose: Show how the draft guidance and task set were selected.</a:t>
+            </a:r>
+          </a:p>
+          <a:p xmlns:a="http://schemas.openxmlformats.org/drawingml/2006/main">
+            <a:r>
+              <a:t>Explain: The starting material comes from official oneCCL documentation, examples, tests, and distributed failure evidence involving rank mismatch, ordering, completion, transport, and plugins.</a:t>
+            </a:r>
+          </a:p>
+          <a:p xmlns:a="http://schemas.openxmlformats.org/drawingml/2006/main">
+            <a:r>
+              <a:t>Emphasize: Maintainers should correct, remove, or replace anything that does not reflect current project practice.</a:t>
             </a:r>
           </a:p>
         </p:txBody>
@@ -913,12 +993,17 @@
           </a:p>
           <a:p xmlns:a="http://schemas.openxmlformats.org/drawingml/2006/main">
             <a:r>
-              <a:t>- https://github.com/uxlfoundation/skills/blob/main/evaluation/harbor/results/2026-08-27-oneccl-zero-count-fixture.md</a:t>
+              <a:t>- https://github.com/uxlfoundation/skills/blob/main/docs/maintainer-review/uxl-oneccl.md</a:t>
             </a:r>
           </a:p>
           <a:p xmlns:a="http://schemas.openxmlformats.org/drawingml/2006/main">
             <a:r>
               <a:t>- https://github.com/uxlfoundation/skills/blob/main/evaluation/harbor/suites.json</a:t>
+            </a:r>
+          </a:p>
+          <a:p xmlns:a="http://schemas.openxmlformats.org/drawingml/2006/main">
+            <a:r>
+              <a:t>- https://github.com/uxlfoundation/skills/blob/main/evaluation/harbor/EVALUATOR_POLICY.md</a:t>
             </a:r>
           </a:p>
           <a:p xmlns:a="http://schemas.openxmlformats.org/drawingml/2006/main">
@@ -933,7 +1018,22 @@
           </a:p>
           <a:p xmlns:a="http://schemas.openxmlformats.org/drawingml/2006/main">
             <a:r>
-              <a:t>Speaker cue: What project ownership would look like</a:t>
+              <a:t>Presenter guidance</a:t>
+            </a:r>
+          </a:p>
+          <a:p xmlns:a="http://schemas.openxmlformats.org/drawingml/2006/main">
+            <a:r>
+              <a:t>Purpose: Clarify the proposed ownership boundary.</a:t>
+            </a:r>
+          </a:p>
+          <a:p xmlns:a="http://schemas.openxmlformats.org/drawingml/2006/main">
+            <a:r>
+              <a:t>Explain: oneCCL maintainers own triggers, API truth, source freshness, limitations, and authentic cases; UXL maintains the catalog, Harbor integration, comparison design, and dashboard.</a:t>
+            </a:r>
+          </a:p>
+          <a:p xmlns:a="http://schemas.openxmlformats.org/drawingml/2006/main">
+            <a:r>
+              <a:t>Emphasize: The skill cannot move beyond its incubating state without named project review.</a:t>
             </a:r>
           </a:p>
         </p:txBody>
@@ -1018,12 +1118,17 @@
           </a:p>
           <a:p xmlns:a="http://schemas.openxmlformats.org/drawingml/2006/main">
             <a:r>
-              <a:t>- https://github.com/uxlfoundation/skills/blob/main/evaluation/harbor/results/2026-08-27-oneccl-zero-count-fixture.md</a:t>
+              <a:t>- https://github.com/uxlfoundation/skills/blob/main/docs/maintainer-review/uxl-oneccl.md</a:t>
             </a:r>
           </a:p>
           <a:p xmlns:a="http://schemas.openxmlformats.org/drawingml/2006/main">
             <a:r>
               <a:t>- https://github.com/uxlfoundation/skills/blob/main/evaluation/harbor/suites.json</a:t>
+            </a:r>
+          </a:p>
+          <a:p xmlns:a="http://schemas.openxmlformats.org/drawingml/2006/main">
+            <a:r>
+              <a:t>- https://github.com/uxlfoundation/skills/blob/main/evaluation/harbor/EVALUATOR_POLICY.md</a:t>
             </a:r>
           </a:p>
           <a:p xmlns:a="http://schemas.openxmlformats.org/drawingml/2006/main">
@@ -1038,7 +1143,22 @@
           </a:p>
           <a:p xmlns:a="http://schemas.openxmlformats.org/drawingml/2006/main">
             <a:r>
-              <a:t>Speaker cue: A focused 30-minute maintainer review</a:t>
+              <a:t>Presenter guidance</a:t>
+            </a:r>
+          </a:p>
+          <a:p xmlns:a="http://schemas.openxmlformats.org/drawingml/2006/main">
+            <a:r>
+              <a:t>Purpose: End with a small, concrete review request.</a:t>
+            </a:r>
+          </a:p>
+          <a:p xmlns:a="http://schemas.openxmlformats.org/drawingml/2006/main">
+            <a:r>
+              <a:t>Explain: Ask maintainers to check the trigger and technical guidance, judge the task inventory, and name a reviewer or owner.</a:t>
+            </a:r>
+          </a:p>
+          <a:p xmlns:a="http://schemas.openxmlformats.org/drawingml/2006/main">
+            <a:r>
+              <a:t>Emphasize: The desired output is specific corrections and realistic cases, not blanket endorsement of the draft.</a:t>
             </a:r>
           </a:p>
         </p:txBody>
@@ -1074,7 +1194,7 @@
     <p:bg>
       <p:bgPr>
         <a:blipFill xmlns:a="http://schemas.openxmlformats.org/drawingml/2006/main">
-          <a:blip xmlns:r="http://schemas.openxmlformats.org/officeDocument/2006/relationships" r:embed="R0fa7fd516c284d0a">
+          <a:blip xmlns:r="http://schemas.openxmlformats.org/officeDocument/2006/relationships" r:embed="R0de0deaf816d455e">
             <a:alphaModFix/>
           </a:blip>
           <a:stretch>
@@ -1509,7 +1629,7 @@
           <p:nvPr/>
         </p:nvPicPr>
         <p:blipFill rotWithShape="1">
-          <a:blip xmlns:r="http://schemas.openxmlformats.org/officeDocument/2006/relationships" xmlns:a="http://schemas.openxmlformats.org/drawingml/2006/main" r:embed="R5c1903a0958a4b4e">
+          <a:blip xmlns:r="http://schemas.openxmlformats.org/officeDocument/2006/relationships" xmlns:a="http://schemas.openxmlformats.org/drawingml/2006/main" r:embed="Rc844d942a3a64a2d">
             <a:alphaModFix/>
           </a:blip>
           <a:srcRect xmlns:a="http://schemas.openxmlformats.org/drawingml/2006/main" l="0" t="0" r="0" b="0"/>
@@ -1539,7 +1659,7 @@
     <p:bg>
       <p:bgPr>
         <a:blipFill xmlns:a="http://schemas.openxmlformats.org/drawingml/2006/main">
-          <a:blip xmlns:r="http://schemas.openxmlformats.org/officeDocument/2006/relationships" r:embed="R18e4cb7744ac4f30">
+          <a:blip xmlns:r="http://schemas.openxmlformats.org/officeDocument/2006/relationships" r:embed="Rebacc530542f4fad">
             <a:alphaModFix/>
           </a:blip>
           <a:stretch>
@@ -2573,7 +2693,7 @@
           <p:nvPr/>
         </p:nvPicPr>
         <p:blipFill rotWithShape="1">
-          <a:blip xmlns:r="http://schemas.openxmlformats.org/officeDocument/2006/relationships" xmlns:a="http://schemas.openxmlformats.org/drawingml/2006/main" r:embed="R49274d62641c4f06">
+          <a:blip xmlns:r="http://schemas.openxmlformats.org/officeDocument/2006/relationships" xmlns:a="http://schemas.openxmlformats.org/drawingml/2006/main" r:embed="R72c17720a237438e">
             <a:alphaModFix/>
           </a:blip>
           <a:srcRect xmlns:a="http://schemas.openxmlformats.org/drawingml/2006/main" l="0" t="0" r="0" b="0"/>
@@ -3597,7 +3717,7 @@
           <p:nvPr/>
         </p:nvPicPr>
         <p:blipFill rotWithShape="1">
-          <a:blip xmlns:r="http://schemas.openxmlformats.org/officeDocument/2006/relationships" xmlns:a="http://schemas.openxmlformats.org/drawingml/2006/main" r:embed="Rb06982f7fb454e72">
+          <a:blip xmlns:r="http://schemas.openxmlformats.org/officeDocument/2006/relationships" xmlns:a="http://schemas.openxmlformats.org/drawingml/2006/main" r:embed="R97f3780074504d6f">
             <a:alphaModFix/>
           </a:blip>
           <a:srcRect xmlns:a="http://schemas.openxmlformats.org/drawingml/2006/main" l="0" t="0" r="0" b="0"/>
@@ -3627,7 +3747,7 @@
     <p:bg>
       <p:bgPr>
         <a:blipFill xmlns:a="http://schemas.openxmlformats.org/drawingml/2006/main">
-          <a:blip xmlns:r="http://schemas.openxmlformats.org/officeDocument/2006/relationships" r:embed="R226dd13fd4024685">
+          <a:blip xmlns:r="http://schemas.openxmlformats.org/officeDocument/2006/relationships" r:embed="R7a7eac06cd8d48df">
             <a:alphaModFix/>
           </a:blip>
           <a:stretch>
@@ -4901,7 +5021,7 @@
           <p:nvPr/>
         </p:nvPicPr>
         <p:blipFill rotWithShape="1">
-          <a:blip xmlns:r="http://schemas.openxmlformats.org/officeDocument/2006/relationships" xmlns:a="http://schemas.openxmlformats.org/drawingml/2006/main" r:embed="R4ff978f10eca4088">
+          <a:blip xmlns:r="http://schemas.openxmlformats.org/officeDocument/2006/relationships" xmlns:a="http://schemas.openxmlformats.org/drawingml/2006/main" r:embed="R74572c3a06e246eb">
             <a:alphaModFix/>
           </a:blip>
           <a:srcRect xmlns:a="http://schemas.openxmlformats.org/drawingml/2006/main" l="0" t="0" r="0" b="0"/>
@@ -8145,7 +8265,7 @@
           <p:nvPr/>
         </p:nvPicPr>
         <p:blipFill rotWithShape="1">
-          <a:blip xmlns:r="http://schemas.openxmlformats.org/officeDocument/2006/relationships" xmlns:a="http://schemas.openxmlformats.org/drawingml/2006/main" r:embed="R1236982942504250">
+          <a:blip xmlns:r="http://schemas.openxmlformats.org/officeDocument/2006/relationships" xmlns:a="http://schemas.openxmlformats.org/drawingml/2006/main" r:embed="Rc37f99a6b32a4c29">
             <a:alphaModFix/>
           </a:blip>
           <a:srcRect xmlns:a="http://schemas.openxmlformats.org/drawingml/2006/main" l="0" t="0" r="0" b="0"/>
@@ -9883,7 +10003,7 @@
           <p:nvPr/>
         </p:nvPicPr>
         <p:blipFill rotWithShape="1">
-          <a:blip xmlns:r="http://schemas.openxmlformats.org/officeDocument/2006/relationships" xmlns:a="http://schemas.openxmlformats.org/drawingml/2006/main" r:embed="Rff5b327dc46c43b3">
+          <a:blip xmlns:r="http://schemas.openxmlformats.org/officeDocument/2006/relationships" xmlns:a="http://schemas.openxmlformats.org/drawingml/2006/main" r:embed="R59122915eff448b8">
             <a:alphaModFix/>
           </a:blip>
           <a:srcRect xmlns:a="http://schemas.openxmlformats.org/drawingml/2006/main" l="0" t="0" r="0" b="0"/>
@@ -16712,7 +16832,7 @@
     <p:bg>
       <p:bgPr>
         <a:blipFill xmlns:a="http://schemas.openxmlformats.org/drawingml/2006/main">
-          <a:blip xmlns:r="http://schemas.openxmlformats.org/officeDocument/2006/relationships" r:embed="R1780b706b99f4fe5">
+          <a:blip xmlns:r="http://schemas.openxmlformats.org/officeDocument/2006/relationships" r:embed="R2a40478dd3a1442f">
             <a:alphaModFix/>
           </a:blip>
           <a:stretch>
@@ -17147,7 +17267,7 @@
           <p:nvPr/>
         </p:nvPicPr>
         <p:blipFill rotWithShape="1">
-          <a:blip xmlns:r="http://schemas.openxmlformats.org/officeDocument/2006/relationships" xmlns:a="http://schemas.openxmlformats.org/drawingml/2006/main" r:embed="Rdd37442a9e8940a6">
+          <a:blip xmlns:r="http://schemas.openxmlformats.org/officeDocument/2006/relationships" xmlns:a="http://schemas.openxmlformats.org/drawingml/2006/main" r:embed="Rd2134248c9474548">
             <a:alphaModFix/>
           </a:blip>
           <a:srcRect xmlns:a="http://schemas.openxmlformats.org/drawingml/2006/main" l="0" t="0" r="0" b="0"/>
@@ -17177,7 +17297,7 @@
     <p:bg>
       <p:bgPr>
         <a:blipFill xmlns:a="http://schemas.openxmlformats.org/drawingml/2006/main">
-          <a:blip xmlns:r="http://schemas.openxmlformats.org/officeDocument/2006/relationships" r:embed="R2f4e6ebb8454423a">
+          <a:blip xmlns:r="http://schemas.openxmlformats.org/officeDocument/2006/relationships" r:embed="R469435b3b4a1464a">
             <a:alphaModFix/>
           </a:blip>
           <a:stretch>
@@ -17810,7 +17930,7 @@
           <p:nvPr/>
         </p:nvPicPr>
         <p:blipFill rotWithShape="1">
-          <a:blip xmlns:r="http://schemas.openxmlformats.org/officeDocument/2006/relationships" xmlns:a="http://schemas.openxmlformats.org/drawingml/2006/main" r:embed="R85e6aa761cb34980">
+          <a:blip xmlns:r="http://schemas.openxmlformats.org/officeDocument/2006/relationships" xmlns:a="http://schemas.openxmlformats.org/drawingml/2006/main" r:embed="R3bcca30187af45c7">
             <a:alphaModFix/>
           </a:blip>
           <a:srcRect xmlns:a="http://schemas.openxmlformats.org/drawingml/2006/main" l="0" t="0" r="0" b="0"/>
@@ -18270,7 +18390,7 @@
     <p:bg>
       <p:bgPr>
         <a:blipFill xmlns:a="http://schemas.openxmlformats.org/drawingml/2006/main">
-          <a:blip xmlns:r="http://schemas.openxmlformats.org/officeDocument/2006/relationships" r:embed="Ree0cb5b201094d84">
+          <a:blip xmlns:r="http://schemas.openxmlformats.org/officeDocument/2006/relationships" r:embed="Reeb1d02c5be34e54">
             <a:alphaModFix/>
           </a:blip>
           <a:stretch>
@@ -18903,7 +19023,7 @@
           <p:nvPr/>
         </p:nvPicPr>
         <p:blipFill rotWithShape="1">
-          <a:blip xmlns:r="http://schemas.openxmlformats.org/officeDocument/2006/relationships" xmlns:a="http://schemas.openxmlformats.org/drawingml/2006/main" r:embed="Rf70c23b3cd3d4052">
+          <a:blip xmlns:r="http://schemas.openxmlformats.org/officeDocument/2006/relationships" xmlns:a="http://schemas.openxmlformats.org/drawingml/2006/main" r:embed="Rdf3482727d8846d5">
             <a:alphaModFix/>
           </a:blip>
           <a:srcRect xmlns:a="http://schemas.openxmlformats.org/drawingml/2006/main" l="0" t="0" r="0" b="0"/>
@@ -21559,7 +21679,7 @@
           <p:nvPr/>
         </p:nvPicPr>
         <p:blipFill rotWithShape="1">
-          <a:blip xmlns:r="http://schemas.openxmlformats.org/officeDocument/2006/relationships" xmlns:a="http://schemas.openxmlformats.org/drawingml/2006/main" r:embed="R28070925d1074bb4">
+          <a:blip xmlns:r="http://schemas.openxmlformats.org/officeDocument/2006/relationships" xmlns:a="http://schemas.openxmlformats.org/drawingml/2006/main" r:embed="Raf7f78b2c8ca4cf5">
             <a:alphaModFix/>
           </a:blip>
           <a:srcRect xmlns:a="http://schemas.openxmlformats.org/drawingml/2006/main" l="0" t="0" r="0" b="0"/>
@@ -21589,7 +21709,7 @@
     <p:bg>
       <p:bgPr>
         <a:blipFill xmlns:a="http://schemas.openxmlformats.org/drawingml/2006/main">
-          <a:blip xmlns:r="http://schemas.openxmlformats.org/officeDocument/2006/relationships" r:embed="R9e0e8be0ee984e55">
+          <a:blip xmlns:r="http://schemas.openxmlformats.org/officeDocument/2006/relationships" r:embed="R180bea0f37be49ac">
             <a:alphaModFix/>
           </a:blip>
           <a:stretch>
@@ -22433,7 +22553,7 @@
           <p:nvPr/>
         </p:nvPicPr>
         <p:blipFill rotWithShape="1">
-          <a:blip xmlns:r="http://schemas.openxmlformats.org/officeDocument/2006/relationships" xmlns:a="http://schemas.openxmlformats.org/drawingml/2006/main" r:embed="R658cc3de10f24f1d">
+          <a:blip xmlns:r="http://schemas.openxmlformats.org/officeDocument/2006/relationships" xmlns:a="http://schemas.openxmlformats.org/drawingml/2006/main" r:embed="R9134fc7f9e3a40bc">
             <a:alphaModFix/>
           </a:blip>
           <a:srcRect xmlns:a="http://schemas.openxmlformats.org/drawingml/2006/main" l="0" t="0" r="0" b="0"/>
@@ -22463,7 +22583,7 @@
     <p:bg>
       <p:bgPr>
         <a:blipFill xmlns:a="http://schemas.openxmlformats.org/drawingml/2006/main">
-          <a:blip xmlns:r="http://schemas.openxmlformats.org/officeDocument/2006/relationships" r:embed="R7e87af6f4871491c">
+          <a:blip xmlns:r="http://schemas.openxmlformats.org/officeDocument/2006/relationships" r:embed="R32a765d2281d468e">
             <a:alphaModFix/>
           </a:blip>
           <a:stretch>
@@ -23411,7 +23531,7 @@
           <p:nvPr/>
         </p:nvPicPr>
         <p:blipFill rotWithShape="1">
-          <a:blip xmlns:r="http://schemas.openxmlformats.org/officeDocument/2006/relationships" xmlns:a="http://schemas.openxmlformats.org/drawingml/2006/main" r:embed="R53de99c2ca2c4b97">
+          <a:blip xmlns:r="http://schemas.openxmlformats.org/officeDocument/2006/relationships" xmlns:a="http://schemas.openxmlformats.org/drawingml/2006/main" r:embed="R272a8987727d4398">
             <a:alphaModFix/>
           </a:blip>
           <a:srcRect xmlns:a="http://schemas.openxmlformats.org/drawingml/2006/main" l="0" t="0" r="0" b="0"/>
@@ -23441,7 +23561,7 @@
     <p:bg>
       <p:bgPr>
         <a:blipFill xmlns:a="http://schemas.openxmlformats.org/drawingml/2006/main">
-          <a:blip xmlns:r="http://schemas.openxmlformats.org/officeDocument/2006/relationships" r:embed="R0c934d4d3daa4765">
+          <a:blip xmlns:r="http://schemas.openxmlformats.org/officeDocument/2006/relationships" r:embed="Ra6dd79a693514dcc">
             <a:alphaModFix/>
           </a:blip>
           <a:stretch>
@@ -23902,7 +24022,7 @@
           <p:nvPr/>
         </p:nvPicPr>
         <p:blipFill rotWithShape="1">
-          <a:blip xmlns:r="http://schemas.openxmlformats.org/officeDocument/2006/relationships" xmlns:a="http://schemas.openxmlformats.org/drawingml/2006/main" r:embed="Rbe4960775d5243ae">
+          <a:blip xmlns:r="http://schemas.openxmlformats.org/officeDocument/2006/relationships" xmlns:a="http://schemas.openxmlformats.org/drawingml/2006/main" r:embed="R8f0a7840f38d44c5">
             <a:alphaModFix/>
           </a:blip>
           <a:srcRect xmlns:a="http://schemas.openxmlformats.org/drawingml/2006/main" l="0" t="0" r="0" b="0"/>
@@ -25614,22 +25734,22 @@
   </p:cSld>
   <p:clrMap bg1="lt1" tx1="dk1" bg2="dk2" tx2="lt2" accent1="accent1" accent2="accent2" accent3="accent3" accent4="accent4" accent5="accent5" accent6="accent6" hlink="hlink" folHlink="folHlink"/>
   <p:sldLayoutIdLst>
-    <p:sldLayoutId xmlns:r="http://schemas.openxmlformats.org/officeDocument/2006/relationships" id="2147483649" r:id="R799ede6a78be464f"/>
-    <p:sldLayoutId xmlns:r="http://schemas.openxmlformats.org/officeDocument/2006/relationships" id="2147483650" r:id="R73d8f3143b344c8b"/>
-    <p:sldLayoutId xmlns:r="http://schemas.openxmlformats.org/officeDocument/2006/relationships" id="2147483651" r:id="R8af6d623281a44bc"/>
-    <p:sldLayoutId xmlns:r="http://schemas.openxmlformats.org/officeDocument/2006/relationships" id="2147483652" r:id="Rd1abece36e67438b"/>
-    <p:sldLayoutId xmlns:r="http://schemas.openxmlformats.org/officeDocument/2006/relationships" id="2147483653" r:id="R12a5d0a2882147df"/>
-    <p:sldLayoutId xmlns:r="http://schemas.openxmlformats.org/officeDocument/2006/relationships" id="2147483654" r:id="R3b23b859f5714009"/>
-    <p:sldLayoutId xmlns:r="http://schemas.openxmlformats.org/officeDocument/2006/relationships" id="2147483655" r:id="Rb348f389456a47a7"/>
-    <p:sldLayoutId xmlns:r="http://schemas.openxmlformats.org/officeDocument/2006/relationships" id="2147483656" r:id="Rf72c8454f50042d7"/>
-    <p:sldLayoutId xmlns:r="http://schemas.openxmlformats.org/officeDocument/2006/relationships" id="2147483657" r:id="Rdb6fd195298f4cfe"/>
-    <p:sldLayoutId xmlns:r="http://schemas.openxmlformats.org/officeDocument/2006/relationships" id="2147483658" r:id="Red9b92bc49e949f7"/>
-    <p:sldLayoutId xmlns:r="http://schemas.openxmlformats.org/officeDocument/2006/relationships" id="2147483659" r:id="Rc13890a80f4a4e9e"/>
-    <p:sldLayoutId xmlns:r="http://schemas.openxmlformats.org/officeDocument/2006/relationships" id="2147483660" r:id="Rb9ace67daa914406"/>
-    <p:sldLayoutId xmlns:r="http://schemas.openxmlformats.org/officeDocument/2006/relationships" id="2147483661" r:id="R393c0f8286b54c3c"/>
-    <p:sldLayoutId xmlns:r="http://schemas.openxmlformats.org/officeDocument/2006/relationships" id="2147483662" r:id="R01a1ba7f9fdb419b"/>
-    <p:sldLayoutId xmlns:r="http://schemas.openxmlformats.org/officeDocument/2006/relationships" id="2147483663" r:id="R722863ce344f410d"/>
-    <p:sldLayoutId xmlns:r="http://schemas.openxmlformats.org/officeDocument/2006/relationships" id="2147483664" r:id="Rc068b8e95221435a"/>
+    <p:sldLayoutId xmlns:r="http://schemas.openxmlformats.org/officeDocument/2006/relationships" id="2147483649" r:id="R61211bbccbec411a"/>
+    <p:sldLayoutId xmlns:r="http://schemas.openxmlformats.org/officeDocument/2006/relationships" id="2147483650" r:id="R0e2a746756e042f7"/>
+    <p:sldLayoutId xmlns:r="http://schemas.openxmlformats.org/officeDocument/2006/relationships" id="2147483651" r:id="R4800b39a9db544be"/>
+    <p:sldLayoutId xmlns:r="http://schemas.openxmlformats.org/officeDocument/2006/relationships" id="2147483652" r:id="R9ae0331a5102453f"/>
+    <p:sldLayoutId xmlns:r="http://schemas.openxmlformats.org/officeDocument/2006/relationships" id="2147483653" r:id="R747a8c92d24b4b31"/>
+    <p:sldLayoutId xmlns:r="http://schemas.openxmlformats.org/officeDocument/2006/relationships" id="2147483654" r:id="R71c15dd5b2794b0f"/>
+    <p:sldLayoutId xmlns:r="http://schemas.openxmlformats.org/officeDocument/2006/relationships" id="2147483655" r:id="R1eb896fcebd74046"/>
+    <p:sldLayoutId xmlns:r="http://schemas.openxmlformats.org/officeDocument/2006/relationships" id="2147483656" r:id="Re3c9924049e64aeb"/>
+    <p:sldLayoutId xmlns:r="http://schemas.openxmlformats.org/officeDocument/2006/relationships" id="2147483657" r:id="Ra6871ae3e0ef42ef"/>
+    <p:sldLayoutId xmlns:r="http://schemas.openxmlformats.org/officeDocument/2006/relationships" id="2147483658" r:id="R1569efb2a4964cb5"/>
+    <p:sldLayoutId xmlns:r="http://schemas.openxmlformats.org/officeDocument/2006/relationships" id="2147483659" r:id="R008408d1729543cb"/>
+    <p:sldLayoutId xmlns:r="http://schemas.openxmlformats.org/officeDocument/2006/relationships" id="2147483660" r:id="Rc0bc69cef5794598"/>
+    <p:sldLayoutId xmlns:r="http://schemas.openxmlformats.org/officeDocument/2006/relationships" id="2147483661" r:id="Rf4779bb132ee4070"/>
+    <p:sldLayoutId xmlns:r="http://schemas.openxmlformats.org/officeDocument/2006/relationships" id="2147483662" r:id="R20604dc47f624b47"/>
+    <p:sldLayoutId xmlns:r="http://schemas.openxmlformats.org/officeDocument/2006/relationships" id="2147483663" r:id="Rfba5369616e44f99"/>
+    <p:sldLayoutId xmlns:r="http://schemas.openxmlformats.org/officeDocument/2006/relationships" id="2147483664" r:id="R36eb804dc1d94106"/>
   </p:sldLayoutIdLst>
   <p:hf hdr="0" ftr="0" dt="0"/>
   <p:txStyles>
@@ -27822,7 +27942,7 @@
           <p:nvPr/>
         </p:nvPicPr>
         <p:blipFill rotWithShape="1">
-          <a:blip xmlns:r="http://schemas.openxmlformats.org/officeDocument/2006/relationships" xmlns:a="http://schemas.openxmlformats.org/drawingml/2006/main" r:embed="R8fbeb4e15b40427e">
+          <a:blip xmlns:r="http://schemas.openxmlformats.org/officeDocument/2006/relationships" xmlns:a="http://schemas.openxmlformats.org/drawingml/2006/main" r:embed="R79bd534448d74c97">
             <a:alphaModFix/>
           </a:blip>
           <a:srcRect xmlns:a="http://schemas.openxmlformats.org/drawingml/2006/main" l="0" t="0" r="0" b="0"/>
@@ -27845,19 +27965,19 @@
   </p:cSld>
   <p:clrMap bg1="lt1" tx1="dk1" bg2="dk2" tx2="lt2" accent1="accent1" accent2="accent2" accent3="accent3" accent4="accent4" accent5="accent5" accent6="accent6" hlink="hlink" folHlink="folHlink"/>
   <p:sldLayoutIdLst>
-    <p:sldLayoutId xmlns:r="http://schemas.openxmlformats.org/officeDocument/2006/relationships" id="2147483666" r:id="R92b7f82a91ca4051"/>
-    <p:sldLayoutId xmlns:r="http://schemas.openxmlformats.org/officeDocument/2006/relationships" id="2147483667" r:id="Rb9b89e204d3d4dcd"/>
-    <p:sldLayoutId xmlns:r="http://schemas.openxmlformats.org/officeDocument/2006/relationships" id="2147483668" r:id="Ra905f8726b27453d"/>
-    <p:sldLayoutId xmlns:r="http://schemas.openxmlformats.org/officeDocument/2006/relationships" id="2147483669" r:id="Rc637ba30ef91406d"/>
-    <p:sldLayoutId xmlns:r="http://schemas.openxmlformats.org/officeDocument/2006/relationships" id="2147483670" r:id="Rda8cd8fcb1cb4a09"/>
-    <p:sldLayoutId xmlns:r="http://schemas.openxmlformats.org/officeDocument/2006/relationships" id="2147483671" r:id="Racdabfdcadad4dac"/>
-    <p:sldLayoutId xmlns:r="http://schemas.openxmlformats.org/officeDocument/2006/relationships" id="2147483672" r:id="R20164493139e46d2"/>
-    <p:sldLayoutId xmlns:r="http://schemas.openxmlformats.org/officeDocument/2006/relationships" id="2147483673" r:id="R6d929edbf50d4c7d"/>
-    <p:sldLayoutId xmlns:r="http://schemas.openxmlformats.org/officeDocument/2006/relationships" id="2147483674" r:id="R6738698598584d79"/>
-    <p:sldLayoutId xmlns:r="http://schemas.openxmlformats.org/officeDocument/2006/relationships" id="2147483675" r:id="Rbc066c5e8da846ee"/>
-    <p:sldLayoutId xmlns:r="http://schemas.openxmlformats.org/officeDocument/2006/relationships" id="2147483676" r:id="R5ce7ad7961b34f24"/>
-    <p:sldLayoutId xmlns:r="http://schemas.openxmlformats.org/officeDocument/2006/relationships" id="2147483677" r:id="R7f1ffd43371048a8"/>
-    <p:sldLayoutId xmlns:r="http://schemas.openxmlformats.org/officeDocument/2006/relationships" id="2147483678" r:id="Rbd2be75ccd5a41fc"/>
+    <p:sldLayoutId xmlns:r="http://schemas.openxmlformats.org/officeDocument/2006/relationships" id="2147483666" r:id="Rcc05f5782cdb4b26"/>
+    <p:sldLayoutId xmlns:r="http://schemas.openxmlformats.org/officeDocument/2006/relationships" id="2147483667" r:id="R9ca4fb2d51fd4a4d"/>
+    <p:sldLayoutId xmlns:r="http://schemas.openxmlformats.org/officeDocument/2006/relationships" id="2147483668" r:id="R11b45eaabe5f4bb3"/>
+    <p:sldLayoutId xmlns:r="http://schemas.openxmlformats.org/officeDocument/2006/relationships" id="2147483669" r:id="Rb48b2b12ae064475"/>
+    <p:sldLayoutId xmlns:r="http://schemas.openxmlformats.org/officeDocument/2006/relationships" id="2147483670" r:id="R2887c73b4bd74c37"/>
+    <p:sldLayoutId xmlns:r="http://schemas.openxmlformats.org/officeDocument/2006/relationships" id="2147483671" r:id="Rd83045b28a304f98"/>
+    <p:sldLayoutId xmlns:r="http://schemas.openxmlformats.org/officeDocument/2006/relationships" id="2147483672" r:id="R67a7dafe473f40ea"/>
+    <p:sldLayoutId xmlns:r="http://schemas.openxmlformats.org/officeDocument/2006/relationships" id="2147483673" r:id="Rcf17fc5a339842ad"/>
+    <p:sldLayoutId xmlns:r="http://schemas.openxmlformats.org/officeDocument/2006/relationships" id="2147483674" r:id="R026bca6e0ce34fd3"/>
+    <p:sldLayoutId xmlns:r="http://schemas.openxmlformats.org/officeDocument/2006/relationships" id="2147483675" r:id="R684c543345cf48ea"/>
+    <p:sldLayoutId xmlns:r="http://schemas.openxmlformats.org/officeDocument/2006/relationships" id="2147483676" r:id="R6752e6fd28e14db5"/>
+    <p:sldLayoutId xmlns:r="http://schemas.openxmlformats.org/officeDocument/2006/relationships" id="2147483677" r:id="R62a5d687596d4277"/>
+    <p:sldLayoutId xmlns:r="http://schemas.openxmlformats.org/officeDocument/2006/relationships" id="2147483678" r:id="R263ead69189242e3"/>
   </p:sldLayoutIdLst>
   <p:hf hdr="0" ftr="0" dt="0"/>
   <p:txStyles>

</xml_diff>